<commit_message>
M04: de-emphasize Canva as the only path, fix Claude image-capability framing (HTML + PPTX)
- Canva Connector reframed as one optional tool for turning copy into a
  finished visual, not the default/only workflow — case study, tip-box,
  Cara Kerja step 3, Latihan, and Output box all now say 'Canva Connector
  kalau aktif, atau tool/desainer lain kalau tidak' instead of assuming Canva
- 'Claude tidak bisa mengedit atau membuat foto langsung' led with a flat
  negative; reframed to lead with the Prompt Enhancer capability first
  (same pattern M03 already uses), limitation folded in rather than leading
- PPTX slides 2, 5, 7 updated to match (text-only run edits, formatting
  preserved), re-rendered via LibreOffice + pdftoppm and visually checked —
  no overflow on any edited text box
</commit_message>
<xml_diff>
--- a/Content-Marketing/M04-Ads-Copywriting/K3-M04-Ads-Copywriting.pptx
+++ b/Content-Marketing/M04-Ads-Copywriting/K3-M04-Ads-Copywriting.pptx
@@ -1869,7 +1869,7 @@
                 <a:ea typeface="Helvetica" pitchFamily="34" charset="-122"/>
                 <a:cs typeface="Helvetica" pitchFamily="34" charset="-120"/>
               </a:rPr>
-              <a:t>REUSE DARI MODUL 3, TIDAK SETUP ULANG</a:t>
+              <a:t>COPY DULU, DESAIN CARA APA SAJA</a:t>
             </a:r>
             <a:endParaRPr lang="en-US" sz="1250" dirty="0"/>
           </a:p>
@@ -1978,7 +1978,7 @@
                 <a:ea typeface="Helvetica" pitchFamily="34" charset="-122"/>
                 <a:cs typeface="Helvetica" pitchFamily="34" charset="-120"/>
               </a:rPr>
-              <a:t>◆  CANVA CONNECTOR — REUSE DARI MODUL 3</a:t>
+              <a:t>◆  OPSIONAL: CANVA CONNECTOR DARI MODUL 3</a:t>
             </a:r>
             <a:endParaRPr lang="en-US" sz="1250" dirty="0"/>
           </a:p>
@@ -2020,7 +2020,7 @@
                 <a:ea typeface="Helvetica" pitchFamily="34" charset="-122"/>
                 <a:cs typeface="Helvetica" pitchFamily="34" charset="-120"/>
               </a:rPr>
-              <a:t>Sudah setup di Modul 3? Tinggal dipakai lagi — tidak perlu setup ulang. Instruksikan: "Buat desain Instagram Story iklan produk ini di Canva, ukuran 1080x1920px, sesuai warna brand di Project-ku" — Claude buka Canva, pilih template, isi teks, hasilkan desain siap download. Belum sempat setup? Balik ke Modul 3 (60 detik), atau ikuti modul ini dengan copy-paste manual ke Canva.</a:t>
+              <a:t>Copy dari Claude bisa dipakai di tool desain apa saja. Kalau kamu pakai Canva dan sudah setup Connector-nya di Modul 3, tinggal dipakai lagi — tidak perlu setup ulang. Instruksikan: "Buat desain Instagram Story iklan produk ini di Canva, ukuran 1080x1920px, sesuai warna brand di Project-ku" — Claude buka Canva, pilih template, isi teks, hasilkan desain siap download. Pakai tool lain? Brief copy-nya tetap langsung dipakai.</a:t>
             </a:r>
             <a:endParaRPr lang="en-US" sz="1200" dirty="0"/>
           </a:p>
@@ -2090,7 +2090,7 @@
                 <a:ea typeface="Helvetica" pitchFamily="34" charset="-122"/>
                 <a:cs typeface="Helvetica" pitchFamily="34" charset="-120"/>
               </a:rPr>
-              <a:t>◆  BUTUH EDIT FOTO PRODUK ATAU VISUAL IKLAN?</a:t>
+              <a:t>◆  BUTUH FOTO PRODUK ATAU VISUAL IKLAN BARU?</a:t>
             </a:r>
             <a:endParaRPr lang="en-US" sz="1250" dirty="0"/>
           </a:p>
@@ -2132,7 +2132,7 @@
                 <a:ea typeface="Helvetica" pitchFamily="34" charset="-122"/>
                 <a:cs typeface="Helvetica" pitchFamily="34" charset="-120"/>
               </a:rPr>
-              <a:t>Claude tidak bisa mengedit atau membuat foto langsung. Untuk edit (crop, retouch, hapus background) pakai Canva atau remove.bg. Untuk visual baru dari nol, pakai pola Prompt Enhancer yang sama seperti Modul 3: jelaskan idemu, Claude tulis prompt detail untuk Nano Banana Pro atau ChatGPT, hasilnya kamu susun jadi desain final di Canva.</a:t>
+              <a:t>Untuk foto produk realistis, Claude bisa jadi Prompt Enhancer — pola yang sama seperti Modul 3: jelaskan idemu, Claude tulis prompt detail untuk Nano Banana Pro atau ChatGPT, hasil gambarnya tinggal disusun jadi desain final. Foto yang sudah ada dan cuma perlu diedit (crop, retouch, hapus background)? Pakai Canva, remove.bg, atau tool lain.</a:t>
             </a:r>
             <a:endParaRPr lang="en-US" sz="1200" dirty="0"/>
           </a:p>
@@ -4439,7 +4439,7 @@
                 <a:ea typeface="Helvetica" pitchFamily="34" charset="-122"/>
                 <a:cs typeface="Helvetica" pitchFamily="34" charset="-120"/>
               </a:rPr>
-              <a:t>pilih variasi terbaik, minta Claude buat desain Canva (ukuran + warna + font)</a:t>
+              <a:t>pilih variasi terbaik, buat desainnya (Canva Connector kalau aktif, atau tool lain)</a:t>
             </a:r>
             <a:endParaRPr lang="en-US" sz="1300" dirty="0"/>
           </a:p>
@@ -4756,7 +4756,7 @@
                 <a:ea typeface="Helvetica" pitchFamily="34" charset="-122"/>
                 <a:cs typeface="Helvetica" pitchFamily="34" charset="-120"/>
               </a:rPr>
-              <a:t>◆  CANVA CONNECTOR AKTIF DARI MODUL 3?  </a:t>
+              <a:t>◆  OPSIONAL: CANVA CONNECTOR DARI MODUL 3?  </a:t>
             </a:r>
             <a:pPr indent="0" marL="0">
               <a:lnSpc>
@@ -4773,7 +4773,7 @@
                 <a:ea typeface="Helvetica" pitchFamily="34" charset="-122"/>
                 <a:cs typeface="Helvetica" pitchFamily="34" charset="-120"/>
               </a:rPr>
-              <a:t>Langkah 2 di atas berjalan otomatis di Canva — kalau belum aktif, tetap bisa ikuti dengan copy-paste manual.</a:t>
+              <a:t>Kalau aktif, Langkah 2 berjalan otomatis di Canva — kalau tidak, pakai brief yang sama untuk desain manual di tool lain.</a:t>
             </a:r>
             <a:endParaRPr lang="en-US" sz="1250" dirty="0"/>
           </a:p>
@@ -6106,7 +6106,7 @@
                 <a:ea typeface="Helvetica" pitchFamily="34" charset="-122"/>
                 <a:cs typeface="Helvetica" pitchFamily="34" charset="-120"/>
               </a:rPr>
-              <a:t>Jalankan prompt ini untuk 1 produk unggulan atau promo yang berjalan. Jika Canva Connector aktif: instruksikan Claude buat desain untuk variasi terbaik langsung di Canva. Jalankan iklan 3 hari, catat CTR dan konversi.</a:t>
+              <a:t>Jalankan prompt ini untuk 1 produk unggulan atau promo yang berjalan. Ambil variasi copy terbaik, lalu buat desainnya — Canva Connector kalau aktif, atau tool lain kalau tidak. Jalankan iklan 3 hari, catat CTR dan konversi.</a:t>
             </a:r>
             <a:endParaRPr lang="en-US" sz="1200" dirty="0"/>
           </a:p>
@@ -6286,7 +6286,7 @@
                 <a:ea typeface="Helvetica" pitchFamily="34" charset="-122"/>
                 <a:cs typeface="Helvetica" pitchFamily="34" charset="-120"/>
               </a:rPr>
-              <a:t>3 variasi copy iklan per platform (Meta, TikTok, Google) siap pakai + 1 targeting brief + minimal 1 desain Canva (via Connector atau manual) + iklan aktif berjalan dengan tracking A/B test.</a:t>
+              <a:t>3 variasi copy iklan per platform (Meta, TikTok, Google) siap pakai + 1 targeting brief + minimal 1 desain siap pakai (Canva, tool lain, atau desainer) + iklan aktif berjalan dengan tracking A/B test.</a:t>
             </a:r>
             <a:endParaRPr lang="en-US" sz="1250" dirty="0"/>
           </a:p>

</xml_diff>

<commit_message>
M04: make the copy+visual+targeting -> Ads Manager assembly step explicit (HTML + PPTX)
Cara Kerja previously jumped from 'buat desain' straight to 'setup campaign
di Ads Manager' without ever saying the design gets uploaded AS the ad
creative alongside the copy and targeting brief — genuinely unclear how the
pieces fit together. Consolidated HTML from 5 steps to 4 (folded targeting
brief into step 1) and added an explicit 'Rakit iklannya di Ads Manager:
upload desain sebagai creative, tempel copy dan targeting brief' step.
PPTX slide 5's filler 'Review Desain' step replaced with the same 'Rakit di
Ads Manager' step; step 1 updated to mention the targeting brief too.
Latihan paragraph updated to match. Re-rendered via LibreOffice, no
overflow.
</commit_message>
<xml_diff>
--- a/Content-Marketing/M04-Ads-Copywriting/K3-M04-Ads-Copywriting.pptx
+++ b/Content-Marketing/M04-Ads-Copywriting/K3-M04-Ads-Copywriting.pptx
@@ -4,6 +4,9 @@
   <p:sldMasterIdLst>
     <p:sldMasterId id="2147483648" r:id="rId1"/>
   </p:sldMasterIdLst>
+  <p:notesMasterIdLst>
+    <p:notesMasterId r:id="rId9"/>
+  </p:notesMasterIdLst>
   <p:sldIdLst>
     <p:sldId id="256" r:id="rId2"/>
     <p:sldId id="257" r:id="rId3"/>
@@ -13,11 +16,8 @@
     <p:sldId id="261" r:id="rId7"/>
     <p:sldId id="262" r:id="rId8"/>
   </p:sldIdLst>
-  <p:notesMasterIdLst>
-    <p:notesMasterId r:id="rId9"/>
-  </p:notesMasterIdLst>
-  <p:sldSz cx="12191695" cy="6858000"/>
-  <p:notesSz cx="6858000" cy="12191695"/>
+  <p:sldSz cx="12192000" cy="6858000"/>
+  <p:notesSz cx="6858000" cy="12192000"/>
   <p:defaultTextStyle>
     <a:lvl1pPr marL="0" algn="l" defTabSz="914400" rtl="0" eaLnBrk="1" latinLnBrk="0" hangingPunct="1">
       <a:defRPr sz="1800" kern="1200">
@@ -110,6 +110,11 @@
       </a:defRPr>
     </a:lvl9pPr>
   </p:defaultTextStyle>
+  <p:extLst>
+    <p:ext uri="{EFAFB233-063F-42B5-8137-9DF3F51BA10A}">
+      <p15:sldGuideLst xmlns:p15="http://schemas.microsoft.com/office/powerpoint/2012/main"/>
+    </p:ext>
+  </p:extLst>
 </p:presentation>
 </file>
 
@@ -135,234 +140,10 @@
           <a:chExt cx="0" cy="0"/>
         </a:xfrm>
       </p:grpSpPr>
-      <p:sp>
-        <p:nvSpPr>
-          <p:cNvPr id="2" name="Header Placeholder 1"/>
-          <p:cNvSpPr>
-            <a:spLocks noGrp="1"/>
-          </p:cNvSpPr>
-          <p:nvPr>
-            <p:ph type="hdr" sz="quarter"/>
-          </p:nvPr>
-        </p:nvSpPr>
-        <p:spPr>
-          <a:xfrm>
-            <a:off x="0" y="0"/>
-            <a:ext cx="2971800" cy="458788"/>
-          </a:xfrm>
-          <a:prstGeom prst="rect">
-            <a:avLst/>
-          </a:prstGeom>
-        </p:spPr>
-        <p:txBody>
-          <a:bodyPr vert="horz" lIns="91440" tIns="45720" rIns="91440" bIns="45720" rtlCol="0"/>
-          <a:lstStyle>
-            <a:lvl1pPr algn="l">
-              <a:defRPr sz="1200"/>
-            </a:lvl1pPr>
-          </a:lstStyle>
-          <a:p>
-            <a:endParaRPr lang="en-US"/>
-          </a:p>
-        </p:txBody>
-      </p:sp>
-      <p:sp>
-        <p:nvSpPr>
-          <p:cNvPr id="3" name="Date Placeholder 2"/>
-          <p:cNvSpPr>
-            <a:spLocks noGrp="1"/>
-          </p:cNvSpPr>
-          <p:nvPr>
-            <p:ph type="dt" idx="1"/>
-          </p:nvPr>
-        </p:nvSpPr>
-        <p:spPr>
-          <a:xfrm>
-            <a:off x="3884613" y="0"/>
-            <a:ext cx="2971800" cy="458788"/>
-          </a:xfrm>
-          <a:prstGeom prst="rect">
-            <a:avLst/>
-          </a:prstGeom>
-        </p:spPr>
-        <p:txBody>
-          <a:bodyPr vert="horz" lIns="91440" tIns="45720" rIns="91440" bIns="45720" rtlCol="0"/>
-          <a:lstStyle>
-            <a:lvl1pPr algn="r">
-              <a:defRPr sz="1200"/>
-            </a:lvl1pPr>
-          </a:lstStyle>
-          <a:p>
-            <a:fld id="{5282F153-3F37-0F45-9E97-73ACFA13230C}" type="datetimeFigureOut">
-              <a:rPr lang="en-US"/>
-              <a:t>7/23/19</a:t>
-            </a:fld>
-            <a:endParaRPr lang="en-US"/>
-          </a:p>
-        </p:txBody>
-      </p:sp>
-      <p:sp>
-        <p:nvSpPr>
-          <p:cNvPr id="4" name="Slide Image Placeholder 3"/>
-          <p:cNvSpPr>
-            <a:spLocks noGrp="1" noRot="1" noChangeAspect="1"/>
-          </p:cNvSpPr>
-          <p:nvPr>
-            <p:ph type="sldImg" idx="2"/>
-          </p:nvPr>
-        </p:nvSpPr>
-        <p:spPr>
-          <a:xfrm>
-            <a:off x="685800" y="1143000"/>
-            <a:ext cx="5486400" cy="3086100"/>
-          </a:xfrm>
-          <a:prstGeom prst="rect">
-            <a:avLst/>
-          </a:prstGeom>
-          <a:noFill/>
-          <a:ln w="12700">
-            <a:solidFill>
-              <a:prstClr val="black"/>
-            </a:solidFill>
-          </a:ln>
-        </p:spPr>
-        <p:txBody>
-          <a:bodyPr vert="horz" lIns="91440" tIns="45720" rIns="91440" bIns="45720" rtlCol="0" anchor="ctr"/>
-          <a:lstStyle/>
-          <a:p>
-            <a:endParaRPr lang="en-US"/>
-          </a:p>
-        </p:txBody>
-      </p:sp>
-      <p:sp>
-        <p:nvSpPr>
-          <p:cNvPr id="5" name="Notes Placeholder 4"/>
-          <p:cNvSpPr>
-            <a:spLocks noGrp="1"/>
-          </p:cNvSpPr>
-          <p:nvPr>
-            <p:ph type="body" sz="quarter" idx="3"/>
-          </p:nvPr>
-        </p:nvSpPr>
-        <p:spPr>
-          <a:xfrm>
-            <a:off x="685800" y="4400550"/>
-            <a:ext cx="5486400" cy="3600450"/>
-          </a:xfrm>
-          <a:prstGeom prst="rect">
-            <a:avLst/>
-          </a:prstGeom>
-        </p:spPr>
-        <p:txBody>
-          <a:bodyPr vert="horz" lIns="91440" tIns="45720" rIns="91440" bIns="45720" rtlCol="0"/>
-          <a:lstStyle/>
-          <a:p>
-            <a:pPr lvl="0"/>
-            <a:r>
-              <a:rPr lang="en-US"/>
-              <a:t>Click to edit Master text styles</a:t>
-            </a:r>
-          </a:p>
-          <a:p>
-            <a:pPr lvl="1"/>
-            <a:r>
-              <a:rPr lang="en-US"/>
-              <a:t>Second level</a:t>
-            </a:r>
-          </a:p>
-          <a:p>
-            <a:pPr lvl="2"/>
-            <a:r>
-              <a:rPr lang="en-US"/>
-              <a:t>Third level</a:t>
-            </a:r>
-          </a:p>
-          <a:p>
-            <a:pPr lvl="3"/>
-            <a:r>
-              <a:rPr lang="en-US"/>
-              <a:t>Fourth level</a:t>
-            </a:r>
-          </a:p>
-          <a:p>
-            <a:pPr lvl="4"/>
-            <a:r>
-              <a:rPr lang="en-US"/>
-              <a:t>Fifth level</a:t>
-            </a:r>
-          </a:p>
-        </p:txBody>
-      </p:sp>
-      <p:sp>
-        <p:nvSpPr>
-          <p:cNvPr id="6" name="Footer Placeholder 5"/>
-          <p:cNvSpPr>
-            <a:spLocks noGrp="1"/>
-          </p:cNvSpPr>
-          <p:nvPr>
-            <p:ph type="ftr" sz="quarter" idx="4"/>
-          </p:nvPr>
-        </p:nvSpPr>
-        <p:spPr>
-          <a:xfrm>
-            <a:off x="0" y="8685213"/>
-            <a:ext cx="2971800" cy="458787"/>
-          </a:xfrm>
-          <a:prstGeom prst="rect">
-            <a:avLst/>
-          </a:prstGeom>
-        </p:spPr>
-        <p:txBody>
-          <a:bodyPr vert="horz" lIns="91440" tIns="45720" rIns="91440" bIns="45720" rtlCol="0" anchor="b"/>
-          <a:lstStyle>
-            <a:lvl1pPr algn="l">
-              <a:defRPr sz="1200"/>
-            </a:lvl1pPr>
-          </a:lstStyle>
-          <a:p>
-            <a:endParaRPr lang="en-US"/>
-          </a:p>
-        </p:txBody>
-      </p:sp>
-      <p:sp>
-        <p:nvSpPr>
-          <p:cNvPr id="7" name="Slide Number Placeholder 6"/>
-          <p:cNvSpPr>
-            <a:spLocks noGrp="1"/>
-          </p:cNvSpPr>
-          <p:nvPr>
-            <p:ph type="sldNum" sz="quarter" idx="5"/>
-          </p:nvPr>
-        </p:nvSpPr>
-        <p:spPr>
-          <a:xfrm>
-            <a:off x="3884613" y="8685213"/>
-            <a:ext cx="2971800" cy="458787"/>
-          </a:xfrm>
-          <a:prstGeom prst="rect">
-            <a:avLst/>
-          </a:prstGeom>
-        </p:spPr>
-        <p:txBody>
-          <a:bodyPr vert="horz" lIns="91440" tIns="45720" rIns="91440" bIns="45720" rtlCol="0" anchor="b"/>
-          <a:lstStyle>
-            <a:lvl1pPr algn="r">
-              <a:defRPr sz="1200"/>
-            </a:lvl1pPr>
-          </a:lstStyle>
-          <a:p>
-            <a:fld id="{CE5E9CC1-C706-0F49-92D6-E571CC5EEA8F}" type="slidenum">
-              <a:rPr lang="en-US"/>
-              <a:t>‹#›</a:t>
-            </a:fld>
-            <a:endParaRPr lang="en-US"/>
-          </a:p>
-        </p:txBody>
-      </p:sp>
     </p:spTree>
     <p:extLst>
       <p:ext uri="{BB962C8B-B14F-4D97-AF65-F5344CB8AC3E}">
-        <p14:creationId xmlns:p14="http://schemas.microsoft.com/office/powerpoint/2010/main" val="1024086991"/>
+        <p14:creationId xmlns:p14="http://schemas.microsoft.com/office/powerpoint/2010/main" val="1174239591"/>
       </p:ext>
     </p:extLst>
   </p:cSld>
@@ -506,10 +287,6 @@
           <a:bodyPr/>
           <a:lstStyle/>
           <a:p>
-            <a:r>
-              <a:rPr lang="en-US" dirty="0"/>
-              <a:t/>
-            </a:r>
             <a:endParaRPr lang="en-US" dirty="0"/>
           </a:p>
         </p:txBody>
@@ -594,10 +371,6 @@
           <a:bodyPr/>
           <a:lstStyle/>
           <a:p>
-            <a:r>
-              <a:rPr lang="en-US" dirty="0"/>
-              <a:t/>
-            </a:r>
             <a:endParaRPr lang="en-US" dirty="0"/>
           </a:p>
         </p:txBody>
@@ -682,10 +455,6 @@
           <a:bodyPr/>
           <a:lstStyle/>
           <a:p>
-            <a:r>
-              <a:rPr lang="en-US" dirty="0"/>
-              <a:t/>
-            </a:r>
             <a:endParaRPr lang="en-US" dirty="0"/>
           </a:p>
         </p:txBody>
@@ -770,10 +539,6 @@
           <a:bodyPr/>
           <a:lstStyle/>
           <a:p>
-            <a:r>
-              <a:rPr lang="en-US" dirty="0"/>
-              <a:t/>
-            </a:r>
             <a:endParaRPr lang="en-US" dirty="0"/>
           </a:p>
         </p:txBody>
@@ -858,10 +623,6 @@
           <a:bodyPr/>
           <a:lstStyle/>
           <a:p>
-            <a:r>
-              <a:rPr lang="en-US" dirty="0"/>
-              <a:t/>
-            </a:r>
             <a:endParaRPr lang="en-US" dirty="0"/>
           </a:p>
         </p:txBody>
@@ -946,10 +707,6 @@
           <a:bodyPr/>
           <a:lstStyle/>
           <a:p>
-            <a:r>
-              <a:rPr lang="en-US" dirty="0"/>
-              <a:t/>
-            </a:r>
             <a:endParaRPr lang="en-US" dirty="0"/>
           </a:p>
         </p:txBody>
@@ -1034,10 +791,6 @@
           <a:bodyPr/>
           <a:lstStyle/>
           <a:p>
-            <a:r>
-              <a:rPr lang="en-US" dirty="0"/>
-              <a:t/>
-            </a:r>
             <a:endParaRPr lang="en-US" dirty="0"/>
           </a:p>
         </p:txBody>
@@ -1111,6 +864,11 @@
 <file path=ppt/slideMasters/slideMaster1.xml><?xml version="1.0" encoding="utf-8"?>
 <p:sldMaster xmlns:a="http://schemas.openxmlformats.org/drawingml/2006/main" xmlns:r="http://schemas.openxmlformats.org/officeDocument/2006/relationships" xmlns:p="http://schemas.openxmlformats.org/presentationml/2006/main">
   <p:cSld>
+    <p:bg>
+      <p:bgRef idx="1001">
+        <a:schemeClr val="bg1"/>
+      </p:bgRef>
+    </p:bg>
     <p:spTree>
       <p:nvGrpSpPr>
         <p:cNvPr id="1" name=""/>
@@ -1393,6 +1151,7 @@
         <a:solidFill>
           <a:srgbClr val="0D1321"/>
         </a:solidFill>
+        <a:effectLst/>
       </p:bgPr>
     </p:bg>
     <p:spTree>
@@ -1430,7 +1189,10 @@
         </p:spPr>
         <p:txBody>
           <a:bodyPr/>
-          <a:p/>
+          <a:lstStyle/>
+          <a:p>
+            <a:endParaRPr/>
+          </a:p>
         </p:txBody>
       </p:sp>
       <p:sp>
@@ -1454,7 +1216,7 @@
           <a:bodyPr wrap="square" lIns="0" tIns="0" rIns="0" bIns="0" rtlCol="0" anchor="ctr"/>
           <a:lstStyle/>
           <a:p>
-            <a:pPr indent="0" marL="0">
+            <a:pPr marL="0" indent="0">
               <a:buNone/>
             </a:pPr>
             <a:r>
@@ -1468,9 +1230,6 @@
               </a:rPr>
               <a:t>belajar</a:t>
             </a:r>
-            <a:pPr indent="0" marL="0">
-              <a:buNone/>
-            </a:pPr>
             <a:r>
               <a:rPr lang="en-US" sz="2000" b="1" dirty="0">
                 <a:solidFill>
@@ -1509,7 +1268,10 @@
         </p:spPr>
         <p:txBody>
           <a:bodyPr/>
-          <a:p/>
+          <a:lstStyle/>
+          <a:p>
+            <a:endParaRPr/>
+          </a:p>
         </p:txBody>
       </p:sp>
       <p:sp>
@@ -1533,7 +1295,7 @@
           <a:bodyPr wrap="square" lIns="0" tIns="0" rIns="0" bIns="0" rtlCol="0" anchor="ctr"/>
           <a:lstStyle/>
           <a:p>
-            <a:pPr algn="ctr" indent="0" marL="0">
+            <a:pPr marL="0" indent="0" algn="ctr">
               <a:buNone/>
             </a:pPr>
             <a:r>
@@ -1572,11 +1334,11 @@
           <a:bodyPr wrap="square" lIns="0" tIns="0" rIns="0" bIns="0" rtlCol="0" anchor="ctr"/>
           <a:lstStyle/>
           <a:p>
-            <a:pPr indent="0" marL="0">
-              <a:buNone/>
-            </a:pPr>
-            <a:r>
-              <a:rPr lang="en-US" sz="1300" b="1" spc="40" kern="0" dirty="0">
+            <a:pPr marL="0" indent="0">
+              <a:buNone/>
+            </a:pPr>
+            <a:r>
+              <a:rPr lang="en-US" sz="1300" b="1" kern="0" spc="40" dirty="0">
                 <a:solidFill>
                   <a:srgbClr val="8B7CF6"/>
                 </a:solidFill>
@@ -1611,7 +1373,7 @@
           <a:bodyPr wrap="square" lIns="0" tIns="0" rIns="0" bIns="0" rtlCol="0" anchor="ctr"/>
           <a:lstStyle/>
           <a:p>
-            <a:pPr indent="0" marL="0">
+            <a:pPr marL="0" indent="0">
               <a:lnSpc>
                 <a:spcPts val="4800"/>
               </a:lnSpc>
@@ -1653,7 +1415,7 @@
           <a:bodyPr wrap="square" lIns="0" tIns="0" rIns="0" bIns="0" rtlCol="0" anchor="ctr"/>
           <a:lstStyle/>
           <a:p>
-            <a:pPr indent="0" marL="0">
+            <a:pPr marL="0" indent="0">
               <a:buNone/>
             </a:pPr>
             <a:r>
@@ -1717,7 +1479,10 @@
         </p:spPr>
         <p:txBody>
           <a:bodyPr/>
-          <a:p/>
+          <a:lstStyle/>
+          <a:p>
+            <a:endParaRPr/>
+          </a:p>
         </p:txBody>
       </p:sp>
       <p:sp>
@@ -1741,7 +1506,10 @@
         </p:spPr>
         <p:txBody>
           <a:bodyPr/>
-          <a:p/>
+          <a:lstStyle/>
+          <a:p>
+            <a:endParaRPr/>
+          </a:p>
         </p:txBody>
       </p:sp>
       <p:sp>
@@ -1765,7 +1533,7 @@
           <a:bodyPr wrap="square" lIns="0" tIns="0" rIns="0" bIns="0" rtlCol="0" anchor="ctr"/>
           <a:lstStyle/>
           <a:p>
-            <a:pPr indent="0" marL="0">
+            <a:pPr marL="0" indent="0">
               <a:buNone/>
             </a:pPr>
             <a:r>
@@ -1779,9 +1547,6 @@
               </a:rPr>
               <a:t>belajar</a:t>
             </a:r>
-            <a:pPr indent="0" marL="0">
-              <a:buNone/>
-            </a:pPr>
             <a:r>
               <a:rPr lang="en-US" sz="2000" b="1" dirty="0">
                 <a:solidFill>
@@ -1818,7 +1583,7 @@
           <a:bodyPr wrap="square" lIns="0" tIns="0" rIns="0" bIns="0" rtlCol="0" anchor="ctr"/>
           <a:lstStyle/>
           <a:p>
-            <a:pPr algn="r" indent="0" marL="0">
+            <a:pPr marL="0" indent="0" algn="r">
               <a:buNone/>
             </a:pPr>
             <a:r>
@@ -1857,11 +1622,11 @@
           <a:bodyPr wrap="square" lIns="0" tIns="0" rIns="0" bIns="0" rtlCol="0" anchor="ctr"/>
           <a:lstStyle/>
           <a:p>
-            <a:pPr indent="0" marL="0">
-              <a:buNone/>
-            </a:pPr>
-            <a:r>
-              <a:rPr lang="en-US" sz="1250" b="1" spc="40" kern="0" dirty="0">
+            <a:pPr marL="0" indent="0">
+              <a:buNone/>
+            </a:pPr>
+            <a:r>
+              <a:rPr lang="en-US" sz="1250" b="1" kern="0" spc="40" dirty="0">
                 <a:solidFill>
                   <a:srgbClr val="4B36C7"/>
                 </a:solidFill>
@@ -1896,7 +1661,7 @@
           <a:bodyPr wrap="square" lIns="0" tIns="0" rIns="0" bIns="0" rtlCol="0" anchor="ctr"/>
           <a:lstStyle/>
           <a:p>
-            <a:pPr indent="0" marL="0">
+            <a:pPr marL="0" indent="0">
               <a:buNone/>
             </a:pPr>
             <a:r>
@@ -1942,7 +1707,10 @@
         </p:spPr>
         <p:txBody>
           <a:bodyPr/>
-          <a:p/>
+          <a:lstStyle/>
+          <a:p>
+            <a:endParaRPr/>
+          </a:p>
         </p:txBody>
       </p:sp>
       <p:sp>
@@ -1966,7 +1734,7 @@
           <a:bodyPr wrap="square" lIns="0" tIns="0" rIns="0" bIns="0" rtlCol="0" anchor="ctr"/>
           <a:lstStyle/>
           <a:p>
-            <a:pPr indent="0" marL="0">
+            <a:pPr marL="0" indent="0">
               <a:buNone/>
             </a:pPr>
             <a:r>
@@ -2005,7 +1773,7 @@
           <a:bodyPr wrap="square" lIns="0" tIns="0" rIns="0" bIns="0" rtlCol="0" anchor="ctr"/>
           <a:lstStyle/>
           <a:p>
-            <a:pPr indent="0" marL="0">
+            <a:pPr marL="0" indent="0">
               <a:lnSpc>
                 <a:spcPct val="125000"/>
               </a:lnSpc>
@@ -2054,7 +1822,10 @@
         </p:spPr>
         <p:txBody>
           <a:bodyPr/>
-          <a:p/>
+          <a:lstStyle/>
+          <a:p>
+            <a:endParaRPr/>
+          </a:p>
         </p:txBody>
       </p:sp>
       <p:sp>
@@ -2078,21 +1849,46 @@
           <a:bodyPr wrap="square" lIns="0" tIns="0" rIns="0" bIns="0" rtlCol="0" anchor="ctr"/>
           <a:lstStyle/>
           <a:p>
-            <a:pPr indent="0" marL="0">
+            <a:pPr marL="0" indent="0">
               <a:buNone/>
             </a:pPr>
             <a:r>
               <a:rPr lang="en-US" sz="1250" b="1" dirty="0">
                 <a:solidFill>
-                  <a:srgbClr val="6B7280"/>
-                </a:solidFill>
-                <a:latin typeface="Helvetica" pitchFamily="34" charset="0"/>
-                <a:ea typeface="Helvetica" pitchFamily="34" charset="-122"/>
-                <a:cs typeface="Helvetica" pitchFamily="34" charset="-120"/>
-              </a:rPr>
-              <a:t>◆  BUTUH FOTO PRODUK ATAU VISUAL IKLAN BARU?</a:t>
-            </a:r>
-            <a:endParaRPr lang="en-US" sz="1250" dirty="0"/>
+                  <a:srgbClr val="4B36C7"/>
+                </a:solidFill>
+                <a:latin typeface="Helvetica" pitchFamily="34" charset="0"/>
+                <a:ea typeface="Helvetica" pitchFamily="34" charset="-122"/>
+                <a:cs typeface="Helvetica" pitchFamily="34" charset="-120"/>
+              </a:rPr>
+              <a:t>◆  </a:t>
+            </a:r>
+            <a:r>
+              <a:rPr lang="en-US" sz="1250" b="1" dirty="0">
+                <a:solidFill>
+                  <a:srgbClr val="4B36C7"/>
+                </a:solidFill>
+                <a:latin typeface="Helvetica" pitchFamily="34" charset="0"/>
+                <a:cs typeface="Helvetica" pitchFamily="34" charset="-120"/>
+              </a:rPr>
+              <a:t>BUTUH</a:t>
+            </a:r>
+            <a:r>
+              <a:rPr lang="en-US" sz="1250" b="1" dirty="0">
+                <a:solidFill>
+                  <a:srgbClr val="4B36C7"/>
+                </a:solidFill>
+                <a:latin typeface="Helvetica" pitchFamily="34" charset="0"/>
+                <a:ea typeface="Helvetica" pitchFamily="34" charset="-122"/>
+                <a:cs typeface="Helvetica" pitchFamily="34" charset="-120"/>
+              </a:rPr>
+              <a:t> FOTO PRODUK ATAU VISUAL IKLAN BARU?</a:t>
+            </a:r>
+            <a:endParaRPr lang="en-US" sz="1250" dirty="0">
+              <a:solidFill>
+                <a:srgbClr val="4B36C7"/>
+              </a:solidFill>
+            </a:endParaRPr>
           </a:p>
         </p:txBody>
       </p:sp>
@@ -2117,7 +1913,7 @@
           <a:bodyPr wrap="square" lIns="0" tIns="0" rIns="0" bIns="0" rtlCol="0" anchor="ctr"/>
           <a:lstStyle/>
           <a:p>
-            <a:pPr indent="0" marL="0">
+            <a:pPr marL="0" indent="0">
               <a:lnSpc>
                 <a:spcPct val="125000"/>
               </a:lnSpc>
@@ -2184,7 +1980,10 @@
         </p:spPr>
         <p:txBody>
           <a:bodyPr/>
-          <a:p/>
+          <a:lstStyle/>
+          <a:p>
+            <a:endParaRPr/>
+          </a:p>
         </p:txBody>
       </p:sp>
       <p:sp>
@@ -2208,7 +2007,10 @@
         </p:spPr>
         <p:txBody>
           <a:bodyPr/>
-          <a:p/>
+          <a:lstStyle/>
+          <a:p>
+            <a:endParaRPr/>
+          </a:p>
         </p:txBody>
       </p:sp>
       <p:sp>
@@ -2232,7 +2034,7 @@
           <a:bodyPr wrap="square" lIns="0" tIns="0" rIns="0" bIns="0" rtlCol="0" anchor="ctr"/>
           <a:lstStyle/>
           <a:p>
-            <a:pPr indent="0" marL="0">
+            <a:pPr marL="0" indent="0">
               <a:buNone/>
             </a:pPr>
             <a:r>
@@ -2246,9 +2048,6 @@
               </a:rPr>
               <a:t>belajar</a:t>
             </a:r>
-            <a:pPr indent="0" marL="0">
-              <a:buNone/>
-            </a:pPr>
             <a:r>
               <a:rPr lang="en-US" sz="2000" b="1" dirty="0">
                 <a:solidFill>
@@ -2285,7 +2084,7 @@
           <a:bodyPr wrap="square" lIns="0" tIns="0" rIns="0" bIns="0" rtlCol="0" anchor="ctr"/>
           <a:lstStyle/>
           <a:p>
-            <a:pPr algn="r" indent="0" marL="0">
+            <a:pPr marL="0" indent="0" algn="r">
               <a:buNone/>
             </a:pPr>
             <a:r>
@@ -2324,11 +2123,11 @@
           <a:bodyPr wrap="square" lIns="0" tIns="0" rIns="0" bIns="0" rtlCol="0" anchor="ctr"/>
           <a:lstStyle/>
           <a:p>
-            <a:pPr indent="0" marL="0">
-              <a:buNone/>
-            </a:pPr>
-            <a:r>
-              <a:rPr lang="en-US" sz="1250" b="1" spc="40" kern="0" dirty="0">
+            <a:pPr marL="0" indent="0">
+              <a:buNone/>
+            </a:pPr>
+            <a:r>
+              <a:rPr lang="en-US" sz="1250" b="1" kern="0" spc="40" dirty="0">
                 <a:solidFill>
                   <a:srgbClr val="4B36C7"/>
                 </a:solidFill>
@@ -2363,7 +2162,7 @@
           <a:bodyPr wrap="square" lIns="0" tIns="0" rIns="0" bIns="0" rtlCol="0" anchor="ctr"/>
           <a:lstStyle/>
           <a:p>
-            <a:pPr indent="0" marL="0">
+            <a:pPr marL="0" indent="0">
               <a:buNone/>
             </a:pPr>
             <a:r>
@@ -2409,7 +2208,10 @@
         </p:spPr>
         <p:txBody>
           <a:bodyPr/>
-          <a:p/>
+          <a:lstStyle/>
+          <a:p>
+            <a:endParaRPr/>
+          </a:p>
         </p:txBody>
       </p:sp>
       <p:sp>
@@ -2433,11 +2235,11 @@
           <a:bodyPr wrap="square" lIns="0" tIns="0" rIns="0" bIns="0" rtlCol="0" anchor="ctr"/>
           <a:lstStyle/>
           <a:p>
-            <a:pPr indent="0" marL="0">
-              <a:buNone/>
-            </a:pPr>
-            <a:r>
-              <a:rPr lang="en-US" sz="1150" b="1" spc="30" kern="0" dirty="0">
+            <a:pPr marL="0" indent="0">
+              <a:buNone/>
+            </a:pPr>
+            <a:r>
+              <a:rPr lang="en-US" sz="1150" b="1" kern="0" spc="30" dirty="0">
                 <a:solidFill>
                   <a:srgbClr val="4B36C7"/>
                 </a:solidFill>
@@ -2472,7 +2274,7 @@
           <a:bodyPr wrap="square" lIns="0" tIns="0" rIns="0" bIns="0" rtlCol="0" anchor="ctr"/>
           <a:lstStyle/>
           <a:p>
-            <a:pPr indent="0" marL="0">
+            <a:pPr marL="0" indent="0">
               <a:lnSpc>
                 <a:spcPct val="120000"/>
               </a:lnSpc>
@@ -2514,7 +2316,7 @@
           <a:bodyPr wrap="square" lIns="0" tIns="0" rIns="0" bIns="0" rtlCol="0" anchor="ctr"/>
           <a:lstStyle/>
           <a:p>
-            <a:pPr algn="ctr" indent="0" marL="0">
+            <a:pPr marL="0" indent="0" algn="ctr">
               <a:buNone/>
             </a:pPr>
             <a:r>
@@ -2560,7 +2362,10 @@
         </p:spPr>
         <p:txBody>
           <a:bodyPr/>
-          <a:p/>
+          <a:lstStyle/>
+          <a:p>
+            <a:endParaRPr/>
+          </a:p>
         </p:txBody>
       </p:sp>
       <p:sp>
@@ -2584,11 +2389,11 @@
           <a:bodyPr wrap="square" lIns="0" tIns="0" rIns="0" bIns="0" rtlCol="0" anchor="ctr"/>
           <a:lstStyle/>
           <a:p>
-            <a:pPr indent="0" marL="0">
-              <a:buNone/>
-            </a:pPr>
-            <a:r>
-              <a:rPr lang="en-US" sz="1150" b="1" spc="30" kern="0" dirty="0">
+            <a:pPr marL="0" indent="0">
+              <a:buNone/>
+            </a:pPr>
+            <a:r>
+              <a:rPr lang="en-US" sz="1150" b="1" kern="0" spc="30" dirty="0">
                 <a:solidFill>
                   <a:srgbClr val="4B36C7"/>
                 </a:solidFill>
@@ -2623,7 +2428,7 @@
           <a:bodyPr wrap="square" lIns="0" tIns="0" rIns="0" bIns="0" rtlCol="0" anchor="ctr"/>
           <a:lstStyle/>
           <a:p>
-            <a:pPr indent="0" marL="0">
+            <a:pPr marL="0" indent="0">
               <a:lnSpc>
                 <a:spcPct val="120000"/>
               </a:lnSpc>
@@ -2665,7 +2470,7 @@
           <a:bodyPr wrap="square" lIns="0" tIns="0" rIns="0" bIns="0" rtlCol="0" anchor="ctr"/>
           <a:lstStyle/>
           <a:p>
-            <a:pPr algn="ctr" indent="0" marL="0">
+            <a:pPr marL="0" indent="0" algn="ctr">
               <a:buNone/>
             </a:pPr>
             <a:r>
@@ -2711,7 +2516,10 @@
         </p:spPr>
         <p:txBody>
           <a:bodyPr/>
-          <a:p/>
+          <a:lstStyle/>
+          <a:p>
+            <a:endParaRPr/>
+          </a:p>
         </p:txBody>
       </p:sp>
       <p:sp>
@@ -2735,11 +2543,11 @@
           <a:bodyPr wrap="square" lIns="0" tIns="0" rIns="0" bIns="0" rtlCol="0" anchor="ctr"/>
           <a:lstStyle/>
           <a:p>
-            <a:pPr indent="0" marL="0">
-              <a:buNone/>
-            </a:pPr>
-            <a:r>
-              <a:rPr lang="en-US" sz="1150" b="1" spc="30" kern="0" dirty="0">
+            <a:pPr marL="0" indent="0">
+              <a:buNone/>
+            </a:pPr>
+            <a:r>
+              <a:rPr lang="en-US" sz="1150" b="1" kern="0" spc="30" dirty="0">
                 <a:solidFill>
                   <a:srgbClr val="4B36C7"/>
                 </a:solidFill>
@@ -2774,7 +2582,7 @@
           <a:bodyPr wrap="square" lIns="0" tIns="0" rIns="0" bIns="0" rtlCol="0" anchor="ctr"/>
           <a:lstStyle/>
           <a:p>
-            <a:pPr indent="0" marL="0">
+            <a:pPr marL="0" indent="0">
               <a:lnSpc>
                 <a:spcPct val="120000"/>
               </a:lnSpc>
@@ -2816,7 +2624,7 @@
           <a:bodyPr wrap="square" lIns="0" tIns="0" rIns="0" bIns="0" rtlCol="0" anchor="ctr"/>
           <a:lstStyle/>
           <a:p>
-            <a:pPr algn="ctr" indent="0" marL="0">
+            <a:pPr marL="0" indent="0" algn="ctr">
               <a:buNone/>
             </a:pPr>
             <a:r>
@@ -2862,7 +2670,10 @@
         </p:spPr>
         <p:txBody>
           <a:bodyPr/>
-          <a:p/>
+          <a:lstStyle/>
+          <a:p>
+            <a:endParaRPr/>
+          </a:p>
         </p:txBody>
       </p:sp>
       <p:sp>
@@ -2886,11 +2697,11 @@
           <a:bodyPr wrap="square" lIns="0" tIns="0" rIns="0" bIns="0" rtlCol="0" anchor="ctr"/>
           <a:lstStyle/>
           <a:p>
-            <a:pPr indent="0" marL="0">
-              <a:buNone/>
-            </a:pPr>
-            <a:r>
-              <a:rPr lang="en-US" sz="1150" b="1" spc="30" kern="0" dirty="0">
+            <a:pPr marL="0" indent="0">
+              <a:buNone/>
+            </a:pPr>
+            <a:r>
+              <a:rPr lang="en-US" sz="1150" b="1" kern="0" spc="30" dirty="0">
                 <a:solidFill>
                   <a:srgbClr val="4B36C7"/>
                 </a:solidFill>
@@ -2925,7 +2736,7 @@
           <a:bodyPr wrap="square" lIns="0" tIns="0" rIns="0" bIns="0" rtlCol="0" anchor="ctr"/>
           <a:lstStyle/>
           <a:p>
-            <a:pPr indent="0" marL="0">
+            <a:pPr marL="0" indent="0">
               <a:lnSpc>
                 <a:spcPct val="120000"/>
               </a:lnSpc>
@@ -2967,7 +2778,7 @@
           <a:bodyPr wrap="square" lIns="0" tIns="0" rIns="0" bIns="0" rtlCol="0" anchor="ctr"/>
           <a:lstStyle/>
           <a:p>
-            <a:pPr indent="0" marL="0">
+            <a:pPr marL="0" indent="0">
               <a:buNone/>
             </a:pPr>
             <a:r>
@@ -2981,9 +2792,6 @@
               </a:rPr>
               <a:t>Selalu buat </a:t>
             </a:r>
-            <a:pPr indent="0" marL="0">
-              <a:buNone/>
-            </a:pPr>
             <a:r>
               <a:rPr lang="en-US" sz="1200" b="1" i="1" dirty="0">
                 <a:solidFill>
@@ -2995,9 +2803,6 @@
               </a:rPr>
               <a:t>3 variasi</a:t>
             </a:r>
-            <a:pPr indent="0" marL="0">
-              <a:buNone/>
-            </a:pPr>
             <a:r>
               <a:rPr lang="en-US" sz="1200" i="1" dirty="0">
                 <a:solidFill>
@@ -3041,7 +2846,10 @@
         </p:spPr>
         <p:txBody>
           <a:bodyPr/>
-          <a:p/>
+          <a:lstStyle/>
+          <a:p>
+            <a:endParaRPr/>
+          </a:p>
         </p:txBody>
       </p:sp>
       <p:sp>
@@ -3065,11 +2873,11 @@
           <a:bodyPr wrap="square" lIns="0" tIns="0" rIns="0" bIns="0" rtlCol="0" anchor="ctr"/>
           <a:lstStyle/>
           <a:p>
-            <a:pPr indent="0" marL="0">
-              <a:buNone/>
-            </a:pPr>
-            <a:r>
-              <a:rPr lang="en-US" sz="1250" b="1" spc="40" kern="0" dirty="0">
+            <a:pPr marL="0" indent="0">
+              <a:buNone/>
+            </a:pPr>
+            <a:r>
+              <a:rPr lang="en-US" sz="1250" b="1" kern="0" spc="40" dirty="0">
                 <a:solidFill>
                   <a:srgbClr val="DC2626"/>
                 </a:solidFill>
@@ -3104,7 +2912,7 @@
           <a:bodyPr wrap="square" lIns="0" tIns="0" rIns="0" bIns="0" rtlCol="0" anchor="ctr"/>
           <a:lstStyle/>
           <a:p>
-            <a:pPr indent="0" marL="0">
+            <a:pPr marL="0" indent="0">
               <a:buNone/>
             </a:pPr>
             <a:r>
@@ -3143,7 +2951,7 @@
           <a:bodyPr wrap="square" lIns="0" tIns="0" rIns="0" bIns="0" rtlCol="0" anchor="ctr"/>
           <a:lstStyle/>
           <a:p>
-            <a:pPr indent="0" marL="0">
+            <a:pPr marL="0" indent="0">
               <a:lnSpc>
                 <a:spcPct val="115000"/>
               </a:lnSpc>
@@ -3185,7 +2993,7 @@
           <a:bodyPr wrap="square" lIns="0" tIns="0" rIns="0" bIns="0" rtlCol="0" anchor="ctr"/>
           <a:lstStyle/>
           <a:p>
-            <a:pPr indent="0" marL="0">
+            <a:pPr marL="0" indent="0">
               <a:buNone/>
             </a:pPr>
             <a:r>
@@ -3224,7 +3032,7 @@
           <a:bodyPr wrap="square" lIns="0" tIns="0" rIns="0" bIns="0" rtlCol="0" anchor="ctr"/>
           <a:lstStyle/>
           <a:p>
-            <a:pPr indent="0" marL="0">
+            <a:pPr marL="0" indent="0">
               <a:lnSpc>
                 <a:spcPct val="115000"/>
               </a:lnSpc>
@@ -3266,7 +3074,7 @@
           <a:bodyPr wrap="square" lIns="0" tIns="0" rIns="0" bIns="0" rtlCol="0" anchor="ctr"/>
           <a:lstStyle/>
           <a:p>
-            <a:pPr indent="0" marL="0">
+            <a:pPr marL="0" indent="0">
               <a:buNone/>
             </a:pPr>
             <a:r>
@@ -3305,7 +3113,7 @@
           <a:bodyPr wrap="square" lIns="0" tIns="0" rIns="0" bIns="0" rtlCol="0" anchor="ctr"/>
           <a:lstStyle/>
           <a:p>
-            <a:pPr indent="0" marL="0">
+            <a:pPr marL="0" indent="0">
               <a:lnSpc>
                 <a:spcPct val="115000"/>
               </a:lnSpc>
@@ -3347,7 +3155,7 @@
           <a:bodyPr wrap="square" lIns="0" tIns="0" rIns="0" bIns="0" rtlCol="0" anchor="ctr"/>
           <a:lstStyle/>
           <a:p>
-            <a:pPr indent="0" marL="0">
+            <a:pPr marL="0" indent="0">
               <a:buNone/>
             </a:pPr>
             <a:r>
@@ -3386,7 +3194,7 @@
           <a:bodyPr wrap="square" lIns="0" tIns="0" rIns="0" bIns="0" rtlCol="0" anchor="ctr"/>
           <a:lstStyle/>
           <a:p>
-            <a:pPr indent="0" marL="0">
+            <a:pPr marL="0" indent="0">
               <a:lnSpc>
                 <a:spcPct val="115000"/>
               </a:lnSpc>
@@ -3453,7 +3261,10 @@
         </p:spPr>
         <p:txBody>
           <a:bodyPr/>
-          <a:p/>
+          <a:lstStyle/>
+          <a:p>
+            <a:endParaRPr/>
+          </a:p>
         </p:txBody>
       </p:sp>
       <p:sp>
@@ -3477,7 +3288,10 @@
         </p:spPr>
         <p:txBody>
           <a:bodyPr/>
-          <a:p/>
+          <a:lstStyle/>
+          <a:p>
+            <a:endParaRPr/>
+          </a:p>
         </p:txBody>
       </p:sp>
       <p:sp>
@@ -3501,7 +3315,7 @@
           <a:bodyPr wrap="square" lIns="0" tIns="0" rIns="0" bIns="0" rtlCol="0" anchor="ctr"/>
           <a:lstStyle/>
           <a:p>
-            <a:pPr indent="0" marL="0">
+            <a:pPr marL="0" indent="0">
               <a:buNone/>
             </a:pPr>
             <a:r>
@@ -3515,9 +3329,6 @@
               </a:rPr>
               <a:t>belajar</a:t>
             </a:r>
-            <a:pPr indent="0" marL="0">
-              <a:buNone/>
-            </a:pPr>
             <a:r>
               <a:rPr lang="en-US" sz="2000" b="1" dirty="0">
                 <a:solidFill>
@@ -3554,7 +3365,7 @@
           <a:bodyPr wrap="square" lIns="0" tIns="0" rIns="0" bIns="0" rtlCol="0" anchor="ctr"/>
           <a:lstStyle/>
           <a:p>
-            <a:pPr algn="r" indent="0" marL="0">
+            <a:pPr marL="0" indent="0" algn="r">
               <a:buNone/>
             </a:pPr>
             <a:r>
@@ -3593,11 +3404,11 @@
           <a:bodyPr wrap="square" lIns="0" tIns="0" rIns="0" bIns="0" rtlCol="0" anchor="ctr"/>
           <a:lstStyle/>
           <a:p>
-            <a:pPr indent="0" marL="0">
-              <a:buNone/>
-            </a:pPr>
-            <a:r>
-              <a:rPr lang="en-US" sz="1250" b="1" spc="40" kern="0" dirty="0">
+            <a:pPr marL="0" indent="0">
+              <a:buNone/>
+            </a:pPr>
+            <a:r>
+              <a:rPr lang="en-US" sz="1250" b="1" kern="0" spc="40" dirty="0">
                 <a:solidFill>
                   <a:srgbClr val="4B36C7"/>
                 </a:solidFill>
@@ -3632,7 +3443,7 @@
           <a:bodyPr wrap="square" lIns="0" tIns="0" rIns="0" bIns="0" rtlCol="0" anchor="ctr"/>
           <a:lstStyle/>
           <a:p>
-            <a:pPr indent="0" marL="0">
+            <a:pPr marL="0" indent="0">
               <a:buNone/>
             </a:pPr>
             <a:r>
@@ -3678,7 +3489,10 @@
         </p:spPr>
         <p:txBody>
           <a:bodyPr/>
-          <a:p/>
+          <a:lstStyle/>
+          <a:p>
+            <a:endParaRPr/>
+          </a:p>
         </p:txBody>
       </p:sp>
       <p:sp>
@@ -3702,7 +3516,7 @@
           <a:bodyPr wrap="square" lIns="0" tIns="0" rIns="0" bIns="0" rtlCol="0" anchor="ctr"/>
           <a:lstStyle/>
           <a:p>
-            <a:pPr indent="0" marL="0">
+            <a:pPr marL="0" indent="0">
               <a:buNone/>
             </a:pPr>
             <a:r>
@@ -3741,7 +3555,7 @@
           <a:bodyPr wrap="square" lIns="0" tIns="0" rIns="0" bIns="0" rtlCol="0" anchor="ctr"/>
           <a:lstStyle/>
           <a:p>
-            <a:pPr indent="0" marL="0">
+            <a:pPr marL="0" indent="0">
               <a:lnSpc>
                 <a:spcPct val="130000"/>
               </a:lnSpc>
@@ -3783,7 +3597,7 @@
           <a:bodyPr wrap="square" lIns="0" tIns="0" rIns="0" bIns="0" rtlCol="0" anchor="ctr"/>
           <a:lstStyle/>
           <a:p>
-            <a:pPr indent="0" marL="0">
+            <a:pPr marL="0" indent="0">
               <a:lnSpc>
                 <a:spcPct val="125000"/>
               </a:lnSpc>
@@ -3812,8 +3626,8 @@
         </p:nvSpPr>
         <p:spPr>
           <a:xfrm>
-            <a:off x="6172200" y="2194560"/>
-            <a:ext cx="5166360" cy="2468880"/>
+            <a:off x="6172200" y="2194559"/>
+            <a:ext cx="5166360" cy="2670049"/>
           </a:xfrm>
           <a:prstGeom prst="roundRect">
             <a:avLst>
@@ -3832,7 +3646,10 @@
         </p:spPr>
         <p:txBody>
           <a:bodyPr/>
-          <a:p/>
+          <a:lstStyle/>
+          <a:p>
+            <a:endParaRPr/>
+          </a:p>
         </p:txBody>
       </p:sp>
       <p:sp>
@@ -3856,7 +3673,7 @@
           <a:bodyPr wrap="square" lIns="0" tIns="0" rIns="0" bIns="0" rtlCol="0" anchor="ctr"/>
           <a:lstStyle/>
           <a:p>
-            <a:pPr indent="0" marL="0">
+            <a:pPr marL="0" indent="0">
               <a:buNone/>
             </a:pPr>
             <a:r>
@@ -3895,7 +3712,7 @@
           <a:bodyPr wrap="square" lIns="0" tIns="0" rIns="0" bIns="0" rtlCol="0" anchor="ctr"/>
           <a:lstStyle/>
           <a:p>
-            <a:pPr indent="0" marL="0">
+            <a:pPr marL="0" indent="0">
               <a:lnSpc>
                 <a:spcPct val="125000"/>
               </a:lnSpc>
@@ -3937,7 +3754,7 @@
           <a:bodyPr wrap="square" lIns="0" tIns="0" rIns="0" bIns="0" rtlCol="0" anchor="ctr"/>
           <a:lstStyle/>
           <a:p>
-            <a:pPr indent="0" marL="0">
+            <a:pPr marL="0" indent="0">
               <a:lnSpc>
                 <a:spcPct val="125000"/>
               </a:lnSpc>
@@ -4004,7 +3821,10 @@
         </p:spPr>
         <p:txBody>
           <a:bodyPr/>
-          <a:p/>
+          <a:lstStyle/>
+          <a:p>
+            <a:endParaRPr/>
+          </a:p>
         </p:txBody>
       </p:sp>
       <p:sp>
@@ -4028,7 +3848,10 @@
         </p:spPr>
         <p:txBody>
           <a:bodyPr/>
-          <a:p/>
+          <a:lstStyle/>
+          <a:p>
+            <a:endParaRPr/>
+          </a:p>
         </p:txBody>
       </p:sp>
       <p:sp>
@@ -4052,7 +3875,7 @@
           <a:bodyPr wrap="square" lIns="0" tIns="0" rIns="0" bIns="0" rtlCol="0" anchor="ctr"/>
           <a:lstStyle/>
           <a:p>
-            <a:pPr indent="0" marL="0">
+            <a:pPr marL="0" indent="0">
               <a:buNone/>
             </a:pPr>
             <a:r>
@@ -4066,9 +3889,6 @@
               </a:rPr>
               <a:t>belajar</a:t>
             </a:r>
-            <a:pPr indent="0" marL="0">
-              <a:buNone/>
-            </a:pPr>
             <a:r>
               <a:rPr lang="en-US" sz="2000" b="1" dirty="0">
                 <a:solidFill>
@@ -4105,7 +3925,7 @@
           <a:bodyPr wrap="square" lIns="0" tIns="0" rIns="0" bIns="0" rtlCol="0" anchor="ctr"/>
           <a:lstStyle/>
           <a:p>
-            <a:pPr algn="r" indent="0" marL="0">
+            <a:pPr marL="0" indent="0" algn="r">
               <a:buNone/>
             </a:pPr>
             <a:r>
@@ -4144,11 +3964,11 @@
           <a:bodyPr wrap="square" lIns="0" tIns="0" rIns="0" bIns="0" rtlCol="0" anchor="ctr"/>
           <a:lstStyle/>
           <a:p>
-            <a:pPr indent="0" marL="0">
-              <a:buNone/>
-            </a:pPr>
-            <a:r>
-              <a:rPr lang="en-US" sz="1250" b="1" spc="40" kern="0" dirty="0">
+            <a:pPr marL="0" indent="0">
+              <a:buNone/>
+            </a:pPr>
+            <a:r>
+              <a:rPr lang="en-US" sz="1250" b="1" kern="0" spc="40" dirty="0">
                 <a:solidFill>
                   <a:srgbClr val="4B36C7"/>
                 </a:solidFill>
@@ -4183,7 +4003,7 @@
           <a:bodyPr wrap="square" lIns="0" tIns="0" rIns="0" bIns="0" rtlCol="0" anchor="ctr"/>
           <a:lstStyle/>
           <a:p>
-            <a:pPr indent="0" marL="0">
+            <a:pPr marL="0" indent="0">
               <a:buNone/>
             </a:pPr>
             <a:r>
@@ -4222,7 +4042,10 @@
         </p:spPr>
         <p:txBody>
           <a:bodyPr/>
-          <a:p/>
+          <a:lstStyle/>
+          <a:p>
+            <a:endParaRPr/>
+          </a:p>
         </p:txBody>
       </p:sp>
       <p:sp>
@@ -4246,7 +4069,7 @@
           <a:bodyPr wrap="square" lIns="0" tIns="0" rIns="0" bIns="0" rtlCol="0" anchor="ctr"/>
           <a:lstStyle/>
           <a:p>
-            <a:pPr algn="ctr" indent="0" marL="0">
+            <a:pPr marL="0" indent="0" algn="ctr">
               <a:buNone/>
             </a:pPr>
             <a:r>
@@ -4272,7 +4095,7 @@
         </p:nvSpPr>
         <p:spPr>
           <a:xfrm>
-            <a:off x="1024128" y="2148840"/>
+            <a:off x="1024128" y="2108072"/>
             <a:ext cx="10607040" cy="548640"/>
           </a:xfrm>
           <a:prstGeom prst="rect">
@@ -4285,7 +4108,7 @@
           <a:bodyPr wrap="square" lIns="0" tIns="0" rIns="0" bIns="0" rtlCol="0" anchor="ctr"/>
           <a:lstStyle/>
           <a:p>
-            <a:pPr indent="0" marL="0">
+            <a:pPr marL="0" indent="0">
               <a:lnSpc>
                 <a:spcPct val="120000"/>
               </a:lnSpc>
@@ -4302,13 +4125,126 @@
               </a:rPr>
               <a:t>Generate 3 Variasi Copy — </a:t>
             </a:r>
-            <a:pPr indent="0" marL="0">
+            <a:r>
+              <a:rPr lang="en-US" sz="1300" dirty="0">
+                <a:solidFill>
+                  <a:srgbClr val="23283A"/>
+                </a:solidFill>
+                <a:latin typeface="Helvetica" pitchFamily="34" charset="0"/>
+                <a:ea typeface="Helvetica" pitchFamily="34" charset="-122"/>
+                <a:cs typeface="Helvetica" pitchFamily="34" charset="-120"/>
+              </a:rPr>
+              <a:t>sesuai framework, platform + target + promo, plus targeting brief</a:t>
+            </a:r>
+            <a:endParaRPr lang="en-US" sz="1300" dirty="0"/>
+          </a:p>
+        </p:txBody>
+      </p:sp>
+      <p:sp>
+        <p:nvSpPr>
+          <p:cNvPr id="11" name="Shape 9"/>
+          <p:cNvSpPr/>
+          <p:nvPr/>
+        </p:nvSpPr>
+        <p:spPr>
+          <a:xfrm>
+            <a:off x="548640" y="2816352"/>
+            <a:ext cx="329184" cy="329184"/>
+          </a:xfrm>
+          <a:prstGeom prst="ellipse">
+            <a:avLst/>
+          </a:prstGeom>
+          <a:solidFill>
+            <a:srgbClr val="6849F6"/>
+          </a:solidFill>
+          <a:ln/>
+        </p:spPr>
+        <p:txBody>
+          <a:bodyPr/>
+          <a:lstStyle/>
+          <a:p>
+            <a:endParaRPr/>
+          </a:p>
+        </p:txBody>
+      </p:sp>
+      <p:sp>
+        <p:nvSpPr>
+          <p:cNvPr id="12" name="Text 10"/>
+          <p:cNvSpPr/>
+          <p:nvPr/>
+        </p:nvSpPr>
+        <p:spPr>
+          <a:xfrm>
+            <a:off x="548640" y="2816352"/>
+            <a:ext cx="329184" cy="329184"/>
+          </a:xfrm>
+          <a:prstGeom prst="rect">
+            <a:avLst/>
+          </a:prstGeom>
+          <a:noFill/>
+          <a:ln/>
+        </p:spPr>
+        <p:txBody>
+          <a:bodyPr wrap="square" lIns="0" tIns="0" rIns="0" bIns="0" rtlCol="0" anchor="ctr"/>
+          <a:lstStyle/>
+          <a:p>
+            <a:pPr marL="0" indent="0" algn="ctr">
+              <a:buNone/>
+            </a:pPr>
+            <a:r>
+              <a:rPr lang="en-US" sz="1300" b="1" dirty="0">
+                <a:solidFill>
+                  <a:srgbClr val="FFFFFF"/>
+                </a:solidFill>
+                <a:latin typeface="Helvetica" pitchFamily="34" charset="0"/>
+                <a:ea typeface="Helvetica" pitchFamily="34" charset="-122"/>
+                <a:cs typeface="Helvetica" pitchFamily="34" charset="-120"/>
+              </a:rPr>
+              <a:t>2</a:t>
+            </a:r>
+            <a:endParaRPr lang="en-US" sz="1300" dirty="0"/>
+          </a:p>
+        </p:txBody>
+      </p:sp>
+      <p:sp>
+        <p:nvSpPr>
+          <p:cNvPr id="13" name="Text 11"/>
+          <p:cNvSpPr/>
+          <p:nvPr/>
+        </p:nvSpPr>
+        <p:spPr>
+          <a:xfrm>
+            <a:off x="1024128" y="2729864"/>
+            <a:ext cx="10607040" cy="548640"/>
+          </a:xfrm>
+          <a:prstGeom prst="rect">
+            <a:avLst/>
+          </a:prstGeom>
+          <a:noFill/>
+          <a:ln/>
+        </p:spPr>
+        <p:txBody>
+          <a:bodyPr wrap="square" lIns="0" tIns="0" rIns="0" bIns="0" rtlCol="0" anchor="ctr"/>
+          <a:lstStyle/>
+          <a:p>
+            <a:pPr marL="0" indent="0">
               <a:lnSpc>
                 <a:spcPct val="120000"/>
               </a:lnSpc>
               <a:buNone/>
             </a:pPr>
             <a:r>
+              <a:rPr lang="en-US" sz="1300" b="1" dirty="0">
+                <a:solidFill>
+                  <a:srgbClr val="0D1321"/>
+                </a:solidFill>
+                <a:latin typeface="Helvetica" pitchFamily="34" charset="0"/>
+                <a:ea typeface="Helvetica" pitchFamily="34" charset="-122"/>
+                <a:cs typeface="Helvetica" pitchFamily="34" charset="-120"/>
+              </a:rPr>
+              <a:t>Pilih &amp; Buat Desain — </a:t>
+            </a:r>
+            <a:r>
               <a:rPr lang="en-US" sz="1300" dirty="0">
                 <a:solidFill>
                   <a:srgbClr val="23283A"/>
@@ -4317,7 +4253,7 @@
                 <a:ea typeface="Helvetica" pitchFamily="34" charset="-122"/>
                 <a:cs typeface="Helvetica" pitchFamily="34" charset="-120"/>
               </a:rPr>
-              <a:t>sesuai framework, spesifik platform + target + promo</a:t>
+              <a:t>pilih variasi terbaik, buat desainnya (Canva Connector kalau aktif, atau tool lain)</a:t>
             </a:r>
             <a:endParaRPr lang="en-US" sz="1300" dirty="0"/>
           </a:p>
@@ -4325,13 +4261,13 @@
       </p:sp>
       <p:sp>
         <p:nvSpPr>
-          <p:cNvPr id="11" name="Shape 9"/>
-          <p:cNvSpPr/>
-          <p:nvPr/>
-        </p:nvSpPr>
-        <p:spPr>
-          <a:xfrm>
-            <a:off x="548640" y="2816352"/>
+          <p:cNvPr id="14" name="Shape 12"/>
+          <p:cNvSpPr/>
+          <p:nvPr/>
+        </p:nvSpPr>
+        <p:spPr>
+          <a:xfrm>
+            <a:off x="548640" y="3438144"/>
             <a:ext cx="329184" cy="329184"/>
           </a:xfrm>
           <a:prstGeom prst="ellipse">
@@ -4344,18 +4280,21 @@
         </p:spPr>
         <p:txBody>
           <a:bodyPr/>
-          <a:p/>
-        </p:txBody>
-      </p:sp>
-      <p:sp>
-        <p:nvSpPr>
-          <p:cNvPr id="12" name="Text 10"/>
-          <p:cNvSpPr/>
-          <p:nvPr/>
-        </p:nvSpPr>
-        <p:spPr>
-          <a:xfrm>
-            <a:off x="548640" y="2816352"/>
+          <a:lstStyle/>
+          <a:p>
+            <a:endParaRPr/>
+          </a:p>
+        </p:txBody>
+      </p:sp>
+      <p:sp>
+        <p:nvSpPr>
+          <p:cNvPr id="15" name="Text 13"/>
+          <p:cNvSpPr/>
+          <p:nvPr/>
+        </p:nvSpPr>
+        <p:spPr>
+          <a:xfrm>
+            <a:off x="548640" y="3438144"/>
             <a:ext cx="329184" cy="329184"/>
           </a:xfrm>
           <a:prstGeom prst="rect">
@@ -4368,7 +4307,7 @@
           <a:bodyPr wrap="square" lIns="0" tIns="0" rIns="0" bIns="0" rtlCol="0" anchor="ctr"/>
           <a:lstStyle/>
           <a:p>
-            <a:pPr algn="ctr" indent="0" marL="0">
+            <a:pPr marL="0" indent="0" algn="ctr">
               <a:buNone/>
             </a:pPr>
             <a:r>
@@ -4380,7 +4319,7 @@
                 <a:ea typeface="Helvetica" pitchFamily="34" charset="-122"/>
                 <a:cs typeface="Helvetica" pitchFamily="34" charset="-120"/>
               </a:rPr>
-              <a:t>2</a:t>
+              <a:t>3</a:t>
             </a:r>
             <a:endParaRPr lang="en-US" sz="1300" dirty="0"/>
           </a:p>
@@ -4388,13 +4327,13 @@
       </p:sp>
       <p:sp>
         <p:nvSpPr>
-          <p:cNvPr id="13" name="Text 11"/>
-          <p:cNvSpPr/>
-          <p:nvPr/>
-        </p:nvSpPr>
-        <p:spPr>
-          <a:xfrm>
-            <a:off x="1024128" y="2770632"/>
+          <p:cNvPr id="16" name="Text 14"/>
+          <p:cNvSpPr/>
+          <p:nvPr/>
+        </p:nvSpPr>
+        <p:spPr>
+          <a:xfrm>
+            <a:off x="1024128" y="3351656"/>
             <a:ext cx="10607040" cy="548640"/>
           </a:xfrm>
           <a:prstGeom prst="rect">
@@ -4407,7 +4346,7 @@
           <a:bodyPr wrap="square" lIns="0" tIns="0" rIns="0" bIns="0" rtlCol="0" anchor="ctr"/>
           <a:lstStyle/>
           <a:p>
-            <a:pPr indent="0" marL="0">
+            <a:pPr marL="0" indent="0">
               <a:lnSpc>
                 <a:spcPct val="120000"/>
               </a:lnSpc>
@@ -4422,258 +4361,127 @@
                 <a:ea typeface="Helvetica" pitchFamily="34" charset="-122"/>
                 <a:cs typeface="Helvetica" pitchFamily="34" charset="-120"/>
               </a:rPr>
-              <a:t>Pilih &amp; Buat Desain — </a:t>
-            </a:r>
-            <a:pPr indent="0" marL="0">
+              <a:t>Rakit di Ads Manager — </a:t>
+            </a:r>
+            <a:r>
+              <a:rPr lang="en-US" sz="1300" dirty="0">
+                <a:solidFill>
+                  <a:srgbClr val="23283A"/>
+                </a:solidFill>
+                <a:latin typeface="Helvetica" pitchFamily="34" charset="0"/>
+                <a:ea typeface="Helvetica" pitchFamily="34" charset="-122"/>
+                <a:cs typeface="Helvetica" pitchFamily="34" charset="-120"/>
+              </a:rPr>
+              <a:t>upload desain sebagai creative, tempel copy &amp; targeting brief dari atas</a:t>
+            </a:r>
+            <a:endParaRPr lang="en-US" sz="1300" dirty="0"/>
+          </a:p>
+        </p:txBody>
+      </p:sp>
+      <p:sp>
+        <p:nvSpPr>
+          <p:cNvPr id="17" name="Shape 15"/>
+          <p:cNvSpPr/>
+          <p:nvPr/>
+        </p:nvSpPr>
+        <p:spPr>
+          <a:xfrm>
+            <a:off x="548640" y="4059936"/>
+            <a:ext cx="329184" cy="329184"/>
+          </a:xfrm>
+          <a:prstGeom prst="ellipse">
+            <a:avLst/>
+          </a:prstGeom>
+          <a:solidFill>
+            <a:srgbClr val="6849F6"/>
+          </a:solidFill>
+          <a:ln/>
+        </p:spPr>
+        <p:txBody>
+          <a:bodyPr/>
+          <a:lstStyle/>
+          <a:p>
+            <a:endParaRPr/>
+          </a:p>
+        </p:txBody>
+      </p:sp>
+      <p:sp>
+        <p:nvSpPr>
+          <p:cNvPr id="18" name="Text 16"/>
+          <p:cNvSpPr/>
+          <p:nvPr/>
+        </p:nvSpPr>
+        <p:spPr>
+          <a:xfrm>
+            <a:off x="548640" y="4059936"/>
+            <a:ext cx="329184" cy="329184"/>
+          </a:xfrm>
+          <a:prstGeom prst="rect">
+            <a:avLst/>
+          </a:prstGeom>
+          <a:noFill/>
+          <a:ln/>
+        </p:spPr>
+        <p:txBody>
+          <a:bodyPr wrap="square" lIns="0" tIns="0" rIns="0" bIns="0" rtlCol="0" anchor="ctr"/>
+          <a:lstStyle/>
+          <a:p>
+            <a:pPr marL="0" indent="0" algn="ctr">
+              <a:buNone/>
+            </a:pPr>
+            <a:r>
+              <a:rPr lang="en-US" sz="1300" b="1" dirty="0">
+                <a:solidFill>
+                  <a:srgbClr val="FFFFFF"/>
+                </a:solidFill>
+                <a:latin typeface="Helvetica" pitchFamily="34" charset="0"/>
+                <a:ea typeface="Helvetica" pitchFamily="34" charset="-122"/>
+                <a:cs typeface="Helvetica" pitchFamily="34" charset="-120"/>
+              </a:rPr>
+              <a:t>4</a:t>
+            </a:r>
+            <a:endParaRPr lang="en-US" sz="1300" dirty="0"/>
+          </a:p>
+        </p:txBody>
+      </p:sp>
+      <p:sp>
+        <p:nvSpPr>
+          <p:cNvPr id="19" name="Text 17"/>
+          <p:cNvSpPr/>
+          <p:nvPr/>
+        </p:nvSpPr>
+        <p:spPr>
+          <a:xfrm>
+            <a:off x="1024128" y="3973448"/>
+            <a:ext cx="10607040" cy="548640"/>
+          </a:xfrm>
+          <a:prstGeom prst="rect">
+            <a:avLst/>
+          </a:prstGeom>
+          <a:noFill/>
+          <a:ln/>
+        </p:spPr>
+        <p:txBody>
+          <a:bodyPr wrap="square" lIns="0" tIns="0" rIns="0" bIns="0" rtlCol="0" anchor="ctr"/>
+          <a:lstStyle/>
+          <a:p>
+            <a:pPr marL="0" indent="0">
               <a:lnSpc>
                 <a:spcPct val="120000"/>
               </a:lnSpc>
               <a:buNone/>
             </a:pPr>
             <a:r>
-              <a:rPr lang="en-US" sz="1300" dirty="0">
-                <a:solidFill>
-                  <a:srgbClr val="23283A"/>
-                </a:solidFill>
-                <a:latin typeface="Helvetica" pitchFamily="34" charset="0"/>
-                <a:ea typeface="Helvetica" pitchFamily="34" charset="-122"/>
-                <a:cs typeface="Helvetica" pitchFamily="34" charset="-120"/>
-              </a:rPr>
-              <a:t>pilih variasi terbaik, buat desainnya (Canva Connector kalau aktif, atau tool lain)</a:t>
-            </a:r>
-            <a:endParaRPr lang="en-US" sz="1300" dirty="0"/>
-          </a:p>
-        </p:txBody>
-      </p:sp>
-      <p:sp>
-        <p:nvSpPr>
-          <p:cNvPr id="14" name="Shape 12"/>
-          <p:cNvSpPr/>
-          <p:nvPr/>
-        </p:nvSpPr>
-        <p:spPr>
-          <a:xfrm>
-            <a:off x="548640" y="3438144"/>
-            <a:ext cx="329184" cy="329184"/>
-          </a:xfrm>
-          <a:prstGeom prst="ellipse">
-            <a:avLst/>
-          </a:prstGeom>
-          <a:solidFill>
-            <a:srgbClr val="6849F6"/>
-          </a:solidFill>
-          <a:ln/>
-        </p:spPr>
-        <p:txBody>
-          <a:bodyPr/>
-          <a:p/>
-        </p:txBody>
-      </p:sp>
-      <p:sp>
-        <p:nvSpPr>
-          <p:cNvPr id="15" name="Text 13"/>
-          <p:cNvSpPr/>
-          <p:nvPr/>
-        </p:nvSpPr>
-        <p:spPr>
-          <a:xfrm>
-            <a:off x="548640" y="3438144"/>
-            <a:ext cx="329184" cy="329184"/>
-          </a:xfrm>
-          <a:prstGeom prst="rect">
-            <a:avLst/>
-          </a:prstGeom>
-          <a:noFill/>
-          <a:ln/>
-        </p:spPr>
-        <p:txBody>
-          <a:bodyPr wrap="square" lIns="0" tIns="0" rIns="0" bIns="0" rtlCol="0" anchor="ctr"/>
-          <a:lstStyle/>
-          <a:p>
-            <a:pPr algn="ctr" indent="0" marL="0">
-              <a:buNone/>
-            </a:pPr>
-            <a:r>
               <a:rPr lang="en-US" sz="1300" b="1" dirty="0">
                 <a:solidFill>
-                  <a:srgbClr val="FFFFFF"/>
-                </a:solidFill>
-                <a:latin typeface="Helvetica" pitchFamily="34" charset="0"/>
-                <a:ea typeface="Helvetica" pitchFamily="34" charset="-122"/>
-                <a:cs typeface="Helvetica" pitchFamily="34" charset="-120"/>
-              </a:rPr>
-              <a:t>3</a:t>
-            </a:r>
-            <a:endParaRPr lang="en-US" sz="1300" dirty="0"/>
-          </a:p>
-        </p:txBody>
-      </p:sp>
-      <p:sp>
-        <p:nvSpPr>
-          <p:cNvPr id="16" name="Text 14"/>
-          <p:cNvSpPr/>
-          <p:nvPr/>
-        </p:nvSpPr>
-        <p:spPr>
-          <a:xfrm>
-            <a:off x="1024128" y="3392424"/>
-            <a:ext cx="10607040" cy="548640"/>
-          </a:xfrm>
-          <a:prstGeom prst="rect">
-            <a:avLst/>
-          </a:prstGeom>
-          <a:noFill/>
-          <a:ln/>
-        </p:spPr>
-        <p:txBody>
-          <a:bodyPr wrap="square" lIns="0" tIns="0" rIns="0" bIns="0" rtlCol="0" anchor="ctr"/>
-          <a:lstStyle/>
-          <a:p>
-            <a:pPr indent="0" marL="0">
-              <a:lnSpc>
-                <a:spcPct val="120000"/>
-              </a:lnSpc>
-              <a:buNone/>
-            </a:pPr>
-            <a:r>
-              <a:rPr lang="en-US" sz="1300" b="1" dirty="0">
-                <a:solidFill>
                   <a:srgbClr val="0D1321"/>
                 </a:solidFill>
                 <a:latin typeface="Helvetica" pitchFamily="34" charset="0"/>
                 <a:ea typeface="Helvetica" pitchFamily="34" charset="-122"/>
                 <a:cs typeface="Helvetica" pitchFamily="34" charset="-120"/>
               </a:rPr>
-              <a:t>Review Desain — </a:t>
-            </a:r>
-            <a:pPr indent="0" marL="0">
-              <a:lnSpc>
-                <a:spcPct val="120000"/>
-              </a:lnSpc>
-              <a:buNone/>
-            </a:pPr>
-            <a:r>
-              <a:rPr lang="en-US" sz="1300" dirty="0">
-                <a:solidFill>
-                  <a:srgbClr val="23283A"/>
-                </a:solidFill>
-                <a:latin typeface="Helvetica" pitchFamily="34" charset="0"/>
-                <a:ea typeface="Helvetica" pitchFamily="34" charset="-122"/>
-                <a:cs typeface="Helvetica" pitchFamily="34" charset="-120"/>
-              </a:rPr>
-              <a:t>sesuaikan warna/foto brand kamu</a:t>
-            </a:r>
-            <a:endParaRPr lang="en-US" sz="1300" dirty="0"/>
-          </a:p>
-        </p:txBody>
-      </p:sp>
-      <p:sp>
-        <p:nvSpPr>
-          <p:cNvPr id="17" name="Shape 15"/>
-          <p:cNvSpPr/>
-          <p:nvPr/>
-        </p:nvSpPr>
-        <p:spPr>
-          <a:xfrm>
-            <a:off x="548640" y="4059936"/>
-            <a:ext cx="329184" cy="329184"/>
-          </a:xfrm>
-          <a:prstGeom prst="ellipse">
-            <a:avLst/>
-          </a:prstGeom>
-          <a:solidFill>
-            <a:srgbClr val="6849F6"/>
-          </a:solidFill>
-          <a:ln/>
-        </p:spPr>
-        <p:txBody>
-          <a:bodyPr/>
-          <a:p/>
-        </p:txBody>
-      </p:sp>
-      <p:sp>
-        <p:nvSpPr>
-          <p:cNvPr id="18" name="Text 16"/>
-          <p:cNvSpPr/>
-          <p:nvPr/>
-        </p:nvSpPr>
-        <p:spPr>
-          <a:xfrm>
-            <a:off x="548640" y="4059936"/>
-            <a:ext cx="329184" cy="329184"/>
-          </a:xfrm>
-          <a:prstGeom prst="rect">
-            <a:avLst/>
-          </a:prstGeom>
-          <a:noFill/>
-          <a:ln/>
-        </p:spPr>
-        <p:txBody>
-          <a:bodyPr wrap="square" lIns="0" tIns="0" rIns="0" bIns="0" rtlCol="0" anchor="ctr"/>
-          <a:lstStyle/>
-          <a:p>
-            <a:pPr algn="ctr" indent="0" marL="0">
-              <a:buNone/>
-            </a:pPr>
-            <a:r>
-              <a:rPr lang="en-US" sz="1300" b="1" dirty="0">
-                <a:solidFill>
-                  <a:srgbClr val="FFFFFF"/>
-                </a:solidFill>
-                <a:latin typeface="Helvetica" pitchFamily="34" charset="0"/>
-                <a:ea typeface="Helvetica" pitchFamily="34" charset="-122"/>
-                <a:cs typeface="Helvetica" pitchFamily="34" charset="-120"/>
-              </a:rPr>
-              <a:t>4</a:t>
-            </a:r>
-            <a:endParaRPr lang="en-US" sz="1300" dirty="0"/>
-          </a:p>
-        </p:txBody>
-      </p:sp>
-      <p:sp>
-        <p:nvSpPr>
-          <p:cNvPr id="19" name="Text 17"/>
-          <p:cNvSpPr/>
-          <p:nvPr/>
-        </p:nvSpPr>
-        <p:spPr>
-          <a:xfrm>
-            <a:off x="1024128" y="4014216"/>
-            <a:ext cx="10607040" cy="548640"/>
-          </a:xfrm>
-          <a:prstGeom prst="rect">
-            <a:avLst/>
-          </a:prstGeom>
-          <a:noFill/>
-          <a:ln/>
-        </p:spPr>
-        <p:txBody>
-          <a:bodyPr wrap="square" lIns="0" tIns="0" rIns="0" bIns="0" rtlCol="0" anchor="ctr"/>
-          <a:lstStyle/>
-          <a:p>
-            <a:pPr indent="0" marL="0">
-              <a:lnSpc>
-                <a:spcPct val="120000"/>
-              </a:lnSpc>
-              <a:buNone/>
-            </a:pPr>
-            <a:r>
-              <a:rPr lang="en-US" sz="1300" b="1" dirty="0">
-                <a:solidFill>
-                  <a:srgbClr val="0D1321"/>
-                </a:solidFill>
-                <a:latin typeface="Helvetica" pitchFamily="34" charset="0"/>
-                <a:ea typeface="Helvetica" pitchFamily="34" charset="-122"/>
-                <a:cs typeface="Helvetica" pitchFamily="34" charset="-120"/>
-              </a:rPr>
               <a:t>Download &amp; Test — </a:t>
             </a:r>
-            <a:pPr indent="0" marL="0">
-              <a:lnSpc>
-                <a:spcPct val="120000"/>
-              </a:lnSpc>
-              <a:buNone/>
-            </a:pPr>
             <a:r>
               <a:rPr lang="en-US" sz="1300" dirty="0">
                 <a:solidFill>
@@ -4717,7 +4525,10 @@
         </p:spPr>
         <p:txBody>
           <a:bodyPr/>
-          <a:p/>
+          <a:lstStyle/>
+          <a:p>
+            <a:endParaRPr/>
+          </a:p>
         </p:txBody>
       </p:sp>
       <p:sp>
@@ -4741,7 +4552,7 @@
           <a:bodyPr wrap="square" lIns="0" tIns="0" rIns="0" bIns="0" rtlCol="0" anchor="ctr"/>
           <a:lstStyle/>
           <a:p>
-            <a:pPr indent="0" marL="0">
+            <a:pPr marL="0" indent="0">
               <a:lnSpc>
                 <a:spcPct val="120000"/>
               </a:lnSpc>
@@ -4758,12 +4569,6 @@
               </a:rPr>
               <a:t>◆  OPSIONAL: CANVA CONNECTOR DARI MODUL 3?  </a:t>
             </a:r>
-            <a:pPr indent="0" marL="0">
-              <a:lnSpc>
-                <a:spcPct val="120000"/>
-              </a:lnSpc>
-              <a:buNone/>
-            </a:pPr>
             <a:r>
               <a:rPr lang="en-US" sz="1250" dirty="0">
                 <a:solidFill>
@@ -4825,7 +4630,10 @@
         </p:spPr>
         <p:txBody>
           <a:bodyPr/>
-          <a:p/>
+          <a:lstStyle/>
+          <a:p>
+            <a:endParaRPr/>
+          </a:p>
         </p:txBody>
       </p:sp>
       <p:sp>
@@ -4849,7 +4657,10 @@
         </p:spPr>
         <p:txBody>
           <a:bodyPr/>
-          <a:p/>
+          <a:lstStyle/>
+          <a:p>
+            <a:endParaRPr/>
+          </a:p>
         </p:txBody>
       </p:sp>
       <p:sp>
@@ -4873,7 +4684,7 @@
           <a:bodyPr wrap="square" lIns="0" tIns="0" rIns="0" bIns="0" rtlCol="0" anchor="ctr"/>
           <a:lstStyle/>
           <a:p>
-            <a:pPr indent="0" marL="0">
+            <a:pPr marL="0" indent="0">
               <a:buNone/>
             </a:pPr>
             <a:r>
@@ -4887,9 +4698,6 @@
               </a:rPr>
               <a:t>belajar</a:t>
             </a:r>
-            <a:pPr indent="0" marL="0">
-              <a:buNone/>
-            </a:pPr>
             <a:r>
               <a:rPr lang="en-US" sz="2000" b="1" dirty="0">
                 <a:solidFill>
@@ -4926,7 +4734,7 @@
           <a:bodyPr wrap="square" lIns="0" tIns="0" rIns="0" bIns="0" rtlCol="0" anchor="ctr"/>
           <a:lstStyle/>
           <a:p>
-            <a:pPr algn="r" indent="0" marL="0">
+            <a:pPr marL="0" indent="0" algn="r">
               <a:buNone/>
             </a:pPr>
             <a:r>
@@ -4965,11 +4773,11 @@
           <a:bodyPr wrap="square" lIns="0" tIns="0" rIns="0" bIns="0" rtlCol="0" anchor="ctr"/>
           <a:lstStyle/>
           <a:p>
-            <a:pPr indent="0" marL="0">
-              <a:buNone/>
-            </a:pPr>
-            <a:r>
-              <a:rPr lang="en-US" sz="1250" b="1" spc="40" kern="0" dirty="0">
+            <a:pPr marL="0" indent="0">
+              <a:buNone/>
+            </a:pPr>
+            <a:r>
+              <a:rPr lang="en-US" sz="1250" b="1" kern="0" spc="40" dirty="0">
                 <a:solidFill>
                   <a:srgbClr val="4B36C7"/>
                 </a:solidFill>
@@ -5004,7 +4812,7 @@
           <a:bodyPr wrap="square" lIns="0" tIns="0" rIns="0" bIns="0" rtlCol="0" anchor="ctr"/>
           <a:lstStyle/>
           <a:p>
-            <a:pPr indent="0" marL="0">
+            <a:pPr marL="0" indent="0">
               <a:buNone/>
             </a:pPr>
             <a:r>
@@ -5043,7 +4851,7 @@
           <a:bodyPr wrap="square" lIns="0" tIns="0" rIns="0" bIns="0" rtlCol="0" anchor="ctr"/>
           <a:lstStyle/>
           <a:p>
-            <a:pPr indent="0" marL="0">
+            <a:pPr marL="0" indent="0">
               <a:lnSpc>
                 <a:spcPct val="120000"/>
               </a:lnSpc>
@@ -5072,7 +4880,7 @@
         </p:nvSpPr>
         <p:spPr>
           <a:xfrm>
-            <a:off x="502920" y="2542032"/>
+            <a:off x="619400" y="2542032"/>
             <a:ext cx="3529584" cy="2011680"/>
           </a:xfrm>
           <a:prstGeom prst="roundRect">
@@ -5092,7 +4900,10 @@
         </p:spPr>
         <p:txBody>
           <a:bodyPr/>
-          <a:p/>
+          <a:lstStyle/>
+          <a:p>
+            <a:endParaRPr/>
+          </a:p>
         </p:txBody>
       </p:sp>
       <p:sp>
@@ -5103,7 +4914,7 @@
         </p:nvSpPr>
         <p:spPr>
           <a:xfrm>
-            <a:off x="502920" y="2542032"/>
+            <a:off x="619400" y="2542032"/>
             <a:ext cx="3529584" cy="73152"/>
           </a:xfrm>
           <a:prstGeom prst="rect">
@@ -5116,7 +4927,10 @@
         </p:spPr>
         <p:txBody>
           <a:bodyPr/>
-          <a:p/>
+          <a:lstStyle/>
+          <a:p>
+            <a:endParaRPr/>
+          </a:p>
         </p:txBody>
       </p:sp>
       <p:sp>
@@ -5127,7 +4941,7 @@
         </p:nvSpPr>
         <p:spPr>
           <a:xfrm>
-            <a:off x="649224" y="2724912"/>
+            <a:off x="765704" y="2724912"/>
             <a:ext cx="868680" cy="256032"/>
           </a:xfrm>
           <a:prstGeom prst="roundRect">
@@ -5142,7 +4956,10 @@
         </p:spPr>
         <p:txBody>
           <a:bodyPr/>
-          <a:p/>
+          <a:lstStyle/>
+          <a:p>
+            <a:endParaRPr/>
+          </a:p>
         </p:txBody>
       </p:sp>
       <p:sp>
@@ -5153,7 +4970,7 @@
         </p:nvSpPr>
         <p:spPr>
           <a:xfrm>
-            <a:off x="649224" y="2724912"/>
+            <a:off x="765704" y="2724912"/>
             <a:ext cx="868680" cy="256032"/>
           </a:xfrm>
           <a:prstGeom prst="rect">
@@ -5166,7 +4983,7 @@
           <a:bodyPr wrap="square" lIns="0" tIns="0" rIns="0" bIns="0" rtlCol="0" anchor="ctr"/>
           <a:lstStyle/>
           <a:p>
-            <a:pPr algn="ctr" indent="0" marL="0">
+            <a:pPr marL="0" indent="0" algn="ctr">
               <a:buNone/>
             </a:pPr>
             <a:r>
@@ -5192,7 +5009,7 @@
         </p:nvSpPr>
         <p:spPr>
           <a:xfrm>
-            <a:off x="649224" y="3054096"/>
+            <a:off x="765704" y="3054096"/>
             <a:ext cx="3236976" cy="320040"/>
           </a:xfrm>
           <a:prstGeom prst="rect">
@@ -5205,7 +5022,7 @@
           <a:bodyPr wrap="square" lIns="0" tIns="0" rIns="0" bIns="0" rtlCol="0" anchor="ctr"/>
           <a:lstStyle/>
           <a:p>
-            <a:pPr indent="0" marL="0">
+            <a:pPr marL="0" indent="0">
               <a:buNone/>
             </a:pPr>
             <a:r>
@@ -5231,7 +5048,7 @@
         </p:nvSpPr>
         <p:spPr>
           <a:xfrm>
-            <a:off x="649224" y="3383280"/>
+            <a:off x="765704" y="3383280"/>
             <a:ext cx="3236976" cy="1051560"/>
           </a:xfrm>
           <a:prstGeom prst="rect">
@@ -5244,7 +5061,7 @@
           <a:bodyPr wrap="square" lIns="0" tIns="0" rIns="0" bIns="0" rtlCol="0" anchor="ctr"/>
           <a:lstStyle/>
           <a:p>
-            <a:pPr indent="0" marL="0">
+            <a:pPr marL="0" indent="0">
               <a:lnSpc>
                 <a:spcPct val="125000"/>
               </a:lnSpc>
@@ -5273,7 +5090,7 @@
         </p:nvSpPr>
         <p:spPr>
           <a:xfrm>
-            <a:off x="4142232" y="2542032"/>
+            <a:off x="4258712" y="2542032"/>
             <a:ext cx="3529584" cy="2011680"/>
           </a:xfrm>
           <a:prstGeom prst="roundRect">
@@ -5293,7 +5110,10 @@
         </p:spPr>
         <p:txBody>
           <a:bodyPr/>
-          <a:p/>
+          <a:lstStyle/>
+          <a:p>
+            <a:endParaRPr/>
+          </a:p>
         </p:txBody>
       </p:sp>
       <p:sp>
@@ -5304,7 +5124,7 @@
         </p:nvSpPr>
         <p:spPr>
           <a:xfrm>
-            <a:off x="4142232" y="2542032"/>
+            <a:off x="4258712" y="2542032"/>
             <a:ext cx="3529584" cy="73152"/>
           </a:xfrm>
           <a:prstGeom prst="rect">
@@ -5317,7 +5137,10 @@
         </p:spPr>
         <p:txBody>
           <a:bodyPr/>
-          <a:p/>
+          <a:lstStyle/>
+          <a:p>
+            <a:endParaRPr/>
+          </a:p>
         </p:txBody>
       </p:sp>
       <p:sp>
@@ -5328,7 +5151,7 @@
         </p:nvSpPr>
         <p:spPr>
           <a:xfrm>
-            <a:off x="4288536" y="2724912"/>
+            <a:off x="4405016" y="2724912"/>
             <a:ext cx="868680" cy="256032"/>
           </a:xfrm>
           <a:prstGeom prst="roundRect">
@@ -5343,7 +5166,10 @@
         </p:spPr>
         <p:txBody>
           <a:bodyPr/>
-          <a:p/>
+          <a:lstStyle/>
+          <a:p>
+            <a:endParaRPr/>
+          </a:p>
         </p:txBody>
       </p:sp>
       <p:sp>
@@ -5354,7 +5180,7 @@
         </p:nvSpPr>
         <p:spPr>
           <a:xfrm>
-            <a:off x="4288536" y="2724912"/>
+            <a:off x="4405016" y="2724912"/>
             <a:ext cx="868680" cy="256032"/>
           </a:xfrm>
           <a:prstGeom prst="rect">
@@ -5367,7 +5193,7 @@
           <a:bodyPr wrap="square" lIns="0" tIns="0" rIns="0" bIns="0" rtlCol="0" anchor="ctr"/>
           <a:lstStyle/>
           <a:p>
-            <a:pPr algn="ctr" indent="0" marL="0">
+            <a:pPr marL="0" indent="0" algn="ctr">
               <a:buNone/>
             </a:pPr>
             <a:r>
@@ -5393,7 +5219,7 @@
         </p:nvSpPr>
         <p:spPr>
           <a:xfrm>
-            <a:off x="4288536" y="3054096"/>
+            <a:off x="4405016" y="3054096"/>
             <a:ext cx="3236976" cy="320040"/>
           </a:xfrm>
           <a:prstGeom prst="rect">
@@ -5406,7 +5232,7 @@
           <a:bodyPr wrap="square" lIns="0" tIns="0" rIns="0" bIns="0" rtlCol="0" anchor="ctr"/>
           <a:lstStyle/>
           <a:p>
-            <a:pPr indent="0" marL="0">
+            <a:pPr marL="0" indent="0">
               <a:buNone/>
             </a:pPr>
             <a:r>
@@ -5432,7 +5258,7 @@
         </p:nvSpPr>
         <p:spPr>
           <a:xfrm>
-            <a:off x="4288536" y="3383280"/>
+            <a:off x="4405016" y="3383280"/>
             <a:ext cx="3236976" cy="1051560"/>
           </a:xfrm>
           <a:prstGeom prst="rect">
@@ -5445,7 +5271,7 @@
           <a:bodyPr wrap="square" lIns="0" tIns="0" rIns="0" bIns="0" rtlCol="0" anchor="ctr"/>
           <a:lstStyle/>
           <a:p>
-            <a:pPr indent="0" marL="0">
+            <a:pPr marL="0" indent="0">
               <a:lnSpc>
                 <a:spcPct val="125000"/>
               </a:lnSpc>
@@ -5474,7 +5300,7 @@
         </p:nvSpPr>
         <p:spPr>
           <a:xfrm>
-            <a:off x="7781544" y="2542032"/>
+            <a:off x="7898024" y="2542032"/>
             <a:ext cx="3529584" cy="2011680"/>
           </a:xfrm>
           <a:prstGeom prst="roundRect">
@@ -5494,7 +5320,10 @@
         </p:spPr>
         <p:txBody>
           <a:bodyPr/>
-          <a:p/>
+          <a:lstStyle/>
+          <a:p>
+            <a:endParaRPr/>
+          </a:p>
         </p:txBody>
       </p:sp>
       <p:sp>
@@ -5505,7 +5334,7 @@
         </p:nvSpPr>
         <p:spPr>
           <a:xfrm>
-            <a:off x="7781544" y="2542032"/>
+            <a:off x="7898024" y="2542032"/>
             <a:ext cx="3529584" cy="73152"/>
           </a:xfrm>
           <a:prstGeom prst="rect">
@@ -5518,7 +5347,10 @@
         </p:spPr>
         <p:txBody>
           <a:bodyPr/>
-          <a:p/>
+          <a:lstStyle/>
+          <a:p>
+            <a:endParaRPr/>
+          </a:p>
         </p:txBody>
       </p:sp>
       <p:sp>
@@ -5529,7 +5361,7 @@
         </p:nvSpPr>
         <p:spPr>
           <a:xfrm>
-            <a:off x="7927848" y="2724912"/>
+            <a:off x="8044328" y="2724912"/>
             <a:ext cx="868680" cy="256032"/>
           </a:xfrm>
           <a:prstGeom prst="roundRect">
@@ -5544,7 +5376,10 @@
         </p:spPr>
         <p:txBody>
           <a:bodyPr/>
-          <a:p/>
+          <a:lstStyle/>
+          <a:p>
+            <a:endParaRPr/>
+          </a:p>
         </p:txBody>
       </p:sp>
       <p:sp>
@@ -5555,7 +5390,7 @@
         </p:nvSpPr>
         <p:spPr>
           <a:xfrm>
-            <a:off x="7927848" y="2724912"/>
+            <a:off x="8044328" y="2724912"/>
             <a:ext cx="868680" cy="256032"/>
           </a:xfrm>
           <a:prstGeom prst="rect">
@@ -5568,7 +5403,7 @@
           <a:bodyPr wrap="square" lIns="0" tIns="0" rIns="0" bIns="0" rtlCol="0" anchor="ctr"/>
           <a:lstStyle/>
           <a:p>
-            <a:pPr algn="ctr" indent="0" marL="0">
+            <a:pPr marL="0" indent="0" algn="ctr">
               <a:buNone/>
             </a:pPr>
             <a:r>
@@ -5594,7 +5429,7 @@
         </p:nvSpPr>
         <p:spPr>
           <a:xfrm>
-            <a:off x="7927848" y="3054096"/>
+            <a:off x="8044328" y="3054096"/>
             <a:ext cx="3236976" cy="320040"/>
           </a:xfrm>
           <a:prstGeom prst="rect">
@@ -5607,7 +5442,7 @@
           <a:bodyPr wrap="square" lIns="0" tIns="0" rIns="0" bIns="0" rtlCol="0" anchor="ctr"/>
           <a:lstStyle/>
           <a:p>
-            <a:pPr indent="0" marL="0">
+            <a:pPr marL="0" indent="0">
               <a:buNone/>
             </a:pPr>
             <a:r>
@@ -5633,7 +5468,7 @@
         </p:nvSpPr>
         <p:spPr>
           <a:xfrm>
-            <a:off x="7927848" y="3383280"/>
+            <a:off x="8044328" y="3383280"/>
             <a:ext cx="3236976" cy="1051560"/>
           </a:xfrm>
           <a:prstGeom prst="rect">
@@ -5646,7 +5481,7 @@
           <a:bodyPr wrap="square" lIns="0" tIns="0" rIns="0" bIns="0" rtlCol="0" anchor="ctr"/>
           <a:lstStyle/>
           <a:p>
-            <a:pPr indent="0" marL="0">
+            <a:pPr marL="0" indent="0">
               <a:lnSpc>
                 <a:spcPct val="125000"/>
               </a:lnSpc>
@@ -5695,7 +5530,10 @@
         </p:spPr>
         <p:txBody>
           <a:bodyPr/>
-          <a:p/>
+          <a:lstStyle/>
+          <a:p>
+            <a:endParaRPr/>
+          </a:p>
         </p:txBody>
       </p:sp>
       <p:sp>
@@ -5719,7 +5557,7 @@
           <a:bodyPr wrap="square" lIns="0" tIns="0" rIns="0" bIns="0" rtlCol="0" anchor="ctr"/>
           <a:lstStyle/>
           <a:p>
-            <a:pPr indent="0" marL="0">
+            <a:pPr marL="0" indent="0">
               <a:lnSpc>
                 <a:spcPct val="125000"/>
               </a:lnSpc>
@@ -5736,12 +5574,6 @@
               </a:rPr>
               <a:t>◆  BONUS: TARGETING BRIEF  </a:t>
             </a:r>
-            <a:pPr indent="0" marL="0">
-              <a:lnSpc>
-                <a:spcPct val="125000"/>
-              </a:lnSpc>
-              <a:buNone/>
-            </a:pPr>
             <a:r>
               <a:rPr lang="en-US" sz="1200" dirty="0">
                 <a:solidFill>
@@ -5803,7 +5635,10 @@
         </p:spPr>
         <p:txBody>
           <a:bodyPr/>
-          <a:p/>
+          <a:lstStyle/>
+          <a:p>
+            <a:endParaRPr/>
+          </a:p>
         </p:txBody>
       </p:sp>
       <p:sp>
@@ -5827,7 +5662,10 @@
         </p:spPr>
         <p:txBody>
           <a:bodyPr/>
-          <a:p/>
+          <a:lstStyle/>
+          <a:p>
+            <a:endParaRPr/>
+          </a:p>
         </p:txBody>
       </p:sp>
       <p:sp>
@@ -5851,7 +5689,7 @@
           <a:bodyPr wrap="square" lIns="0" tIns="0" rIns="0" bIns="0" rtlCol="0" anchor="ctr"/>
           <a:lstStyle/>
           <a:p>
-            <a:pPr indent="0" marL="0">
+            <a:pPr marL="0" indent="0">
               <a:buNone/>
             </a:pPr>
             <a:r>
@@ -5865,9 +5703,6 @@
               </a:rPr>
               <a:t>belajar</a:t>
             </a:r>
-            <a:pPr indent="0" marL="0">
-              <a:buNone/>
-            </a:pPr>
             <a:r>
               <a:rPr lang="en-US" sz="2000" b="1" dirty="0">
                 <a:solidFill>
@@ -5904,7 +5739,7 @@
           <a:bodyPr wrap="square" lIns="0" tIns="0" rIns="0" bIns="0" rtlCol="0" anchor="ctr"/>
           <a:lstStyle/>
           <a:p>
-            <a:pPr algn="r" indent="0" marL="0">
+            <a:pPr marL="0" indent="0" algn="r">
               <a:buNone/>
             </a:pPr>
             <a:r>
@@ -5943,11 +5778,11 @@
           <a:bodyPr wrap="square" lIns="0" tIns="0" rIns="0" bIns="0" rtlCol="0" anchor="ctr"/>
           <a:lstStyle/>
           <a:p>
-            <a:pPr indent="0" marL="0">
-              <a:buNone/>
-            </a:pPr>
-            <a:r>
-              <a:rPr lang="en-US" sz="1250" b="1" spc="40" kern="0" dirty="0">
+            <a:pPr marL="0" indent="0">
+              <a:buNone/>
+            </a:pPr>
+            <a:r>
+              <a:rPr lang="en-US" sz="1250" b="1" kern="0" spc="40" dirty="0">
                 <a:solidFill>
                   <a:srgbClr val="4B36C7"/>
                 </a:solidFill>
@@ -5982,7 +5817,7 @@
           <a:bodyPr wrap="square" lIns="0" tIns="0" rIns="0" bIns="0" rtlCol="0" anchor="ctr"/>
           <a:lstStyle/>
           <a:p>
-            <a:pPr indent="0" marL="0">
+            <a:pPr marL="0" indent="0">
               <a:buNone/>
             </a:pPr>
             <a:r>
@@ -6028,7 +5863,10 @@
         </p:spPr>
         <p:txBody>
           <a:bodyPr/>
-          <a:p/>
+          <a:lstStyle/>
+          <a:p>
+            <a:endParaRPr/>
+          </a:p>
         </p:txBody>
       </p:sp>
       <p:sp>
@@ -6052,7 +5890,7 @@
           <a:bodyPr wrap="square" lIns="0" tIns="0" rIns="0" bIns="0" rtlCol="0" anchor="ctr"/>
           <a:lstStyle/>
           <a:p>
-            <a:pPr indent="0" marL="0">
+            <a:pPr marL="0" indent="0">
               <a:buNone/>
             </a:pPr>
             <a:r>
@@ -6091,7 +5929,7 @@
           <a:bodyPr wrap="square" lIns="0" tIns="0" rIns="0" bIns="0" rtlCol="0" anchor="ctr"/>
           <a:lstStyle/>
           <a:p>
-            <a:pPr indent="0" marL="0">
+            <a:pPr marL="0" indent="0">
               <a:lnSpc>
                 <a:spcPct val="125000"/>
               </a:lnSpc>
@@ -6140,7 +5978,10 @@
         </p:spPr>
         <p:txBody>
           <a:bodyPr/>
-          <a:p/>
+          <a:lstStyle/>
+          <a:p>
+            <a:endParaRPr/>
+          </a:p>
         </p:txBody>
       </p:sp>
       <p:sp>
@@ -6164,7 +6005,7 @@
           <a:bodyPr wrap="square" lIns="0" tIns="0" rIns="0" bIns="0" rtlCol="0" anchor="ctr"/>
           <a:lstStyle/>
           <a:p>
-            <a:pPr indent="0" marL="0">
+            <a:pPr marL="0" indent="0">
               <a:lnSpc>
                 <a:spcPct val="120000"/>
               </a:lnSpc>
@@ -6208,7 +6049,10 @@
         </p:spPr>
         <p:txBody>
           <a:bodyPr/>
-          <a:p/>
+          <a:lstStyle/>
+          <a:p>
+            <a:endParaRPr/>
+          </a:p>
         </p:txBody>
       </p:sp>
       <p:sp>
@@ -6232,7 +6076,7 @@
           <a:bodyPr wrap="square" lIns="0" tIns="0" rIns="0" bIns="0" rtlCol="0" anchor="ctr"/>
           <a:lstStyle/>
           <a:p>
-            <a:pPr indent="0" marL="0">
+            <a:pPr marL="0" indent="0">
               <a:buNone/>
             </a:pPr>
             <a:r>
@@ -6271,7 +6115,7 @@
           <a:bodyPr wrap="square" lIns="0" tIns="0" rIns="0" bIns="0" rtlCol="0" anchor="ctr"/>
           <a:lstStyle/>
           <a:p>
-            <a:pPr indent="0" marL="0">
+            <a:pPr marL="0" indent="0">
               <a:lnSpc>
                 <a:spcPct val="130000"/>
               </a:lnSpc>
@@ -6593,4 +6437,319 @@
     </a:ext>
   </a:extLst>
 </a:theme>
+</file>
+
+<file path=ppt/theme/theme2.xml><?xml version="1.0" encoding="utf-8"?>
+<a:theme xmlns:a="http://schemas.openxmlformats.org/drawingml/2006/main" name="Office Theme">
+  <a:themeElements>
+    <a:clrScheme name="Office">
+      <a:dk1>
+        <a:sysClr val="windowText" lastClr="000000"/>
+      </a:dk1>
+      <a:lt1>
+        <a:sysClr val="window" lastClr="FFFFFF"/>
+      </a:lt1>
+      <a:dk2>
+        <a:srgbClr val="0E2841"/>
+      </a:dk2>
+      <a:lt2>
+        <a:srgbClr val="E8E8E8"/>
+      </a:lt2>
+      <a:accent1>
+        <a:srgbClr val="156082"/>
+      </a:accent1>
+      <a:accent2>
+        <a:srgbClr val="E97132"/>
+      </a:accent2>
+      <a:accent3>
+        <a:srgbClr val="196B24"/>
+      </a:accent3>
+      <a:accent4>
+        <a:srgbClr val="0F9ED5"/>
+      </a:accent4>
+      <a:accent5>
+        <a:srgbClr val="A02B93"/>
+      </a:accent5>
+      <a:accent6>
+        <a:srgbClr val="4EA72E"/>
+      </a:accent6>
+      <a:hlink>
+        <a:srgbClr val="467886"/>
+      </a:hlink>
+      <a:folHlink>
+        <a:srgbClr val="96607D"/>
+      </a:folHlink>
+    </a:clrScheme>
+    <a:fontScheme name="Office">
+      <a:majorFont>
+        <a:latin typeface="Aptos Display" panose="02110004020202020204"/>
+        <a:ea typeface=""/>
+        <a:cs typeface=""/>
+        <a:font script="Jpan" typeface="游ゴシック Light"/>
+        <a:font script="Hang" typeface="맑은 고딕"/>
+        <a:font script="Hans" typeface="等线 Light"/>
+        <a:font script="Hant" typeface="新細明體"/>
+        <a:font script="Arab" typeface="Times New Roman"/>
+        <a:font script="Hebr" typeface="Times New Roman"/>
+        <a:font script="Thai" typeface="Angsana New"/>
+        <a:font script="Ethi" typeface="Nyala"/>
+        <a:font script="Beng" typeface="Vrinda"/>
+        <a:font script="Gujr" typeface="Shruti"/>
+        <a:font script="Khmr" typeface="MoolBoran"/>
+        <a:font script="Knda" typeface="Tunga"/>
+        <a:font script="Guru" typeface="Raavi"/>
+        <a:font script="Cans" typeface="Euphemia"/>
+        <a:font script="Cher" typeface="Plantagenet Cherokee"/>
+        <a:font script="Yiii" typeface="Microsoft Yi Baiti"/>
+        <a:font script="Tibt" typeface="Microsoft Himalaya"/>
+        <a:font script="Thaa" typeface="MV Boli"/>
+        <a:font script="Deva" typeface="Mangal"/>
+        <a:font script="Telu" typeface="Gautami"/>
+        <a:font script="Taml" typeface="Latha"/>
+        <a:font script="Syrc" typeface="Estrangelo Edessa"/>
+        <a:font script="Orya" typeface="Kalinga"/>
+        <a:font script="Mlym" typeface="Kartika"/>
+        <a:font script="Laoo" typeface="DokChampa"/>
+        <a:font script="Sinh" typeface="Iskoola Pota"/>
+        <a:font script="Mong" typeface="Mongolian Baiti"/>
+        <a:font script="Viet" typeface="Times New Roman"/>
+        <a:font script="Uigh" typeface="Microsoft Uighur"/>
+        <a:font script="Geor" typeface="Sylfaen"/>
+        <a:font script="Armn" typeface="Arial"/>
+        <a:font script="Bugi" typeface="Leelawadee UI"/>
+        <a:font script="Bopo" typeface="Microsoft JhengHei"/>
+        <a:font script="Java" typeface="Javanese Text"/>
+        <a:font script="Lisu" typeface="Segoe UI"/>
+        <a:font script="Mymr" typeface="Myanmar Text"/>
+        <a:font script="Nkoo" typeface="Ebrima"/>
+        <a:font script="Olck" typeface="Nirmala UI"/>
+        <a:font script="Osma" typeface="Ebrima"/>
+        <a:font script="Phag" typeface="Phagspa"/>
+        <a:font script="Syrn" typeface="Estrangelo Edessa"/>
+        <a:font script="Syrj" typeface="Estrangelo Edessa"/>
+        <a:font script="Syre" typeface="Estrangelo Edessa"/>
+        <a:font script="Sora" typeface="Nirmala UI"/>
+        <a:font script="Tale" typeface="Microsoft Tai Le"/>
+        <a:font script="Talu" typeface="Microsoft New Tai Lue"/>
+        <a:font script="Tfng" typeface="Ebrima"/>
+      </a:majorFont>
+      <a:minorFont>
+        <a:latin typeface="Aptos" panose="02110004020202020204"/>
+        <a:ea typeface=""/>
+        <a:cs typeface=""/>
+        <a:font script="Jpan" typeface="游ゴシック"/>
+        <a:font script="Hang" typeface="맑은 고딕"/>
+        <a:font script="Hans" typeface="等线"/>
+        <a:font script="Hant" typeface="新細明體"/>
+        <a:font script="Arab" typeface="Arial"/>
+        <a:font script="Hebr" typeface="Arial"/>
+        <a:font script="Thai" typeface="Cordia New"/>
+        <a:font script="Ethi" typeface="Nyala"/>
+        <a:font script="Beng" typeface="Vrinda"/>
+        <a:font script="Gujr" typeface="Shruti"/>
+        <a:font script="Khmr" typeface="DaunPenh"/>
+        <a:font script="Knda" typeface="Tunga"/>
+        <a:font script="Guru" typeface="Raavi"/>
+        <a:font script="Cans" typeface="Euphemia"/>
+        <a:font script="Cher" typeface="Plantagenet Cherokee"/>
+        <a:font script="Yiii" typeface="Microsoft Yi Baiti"/>
+        <a:font script="Tibt" typeface="Microsoft Himalaya"/>
+        <a:font script="Thaa" typeface="MV Boli"/>
+        <a:font script="Deva" typeface="Mangal"/>
+        <a:font script="Telu" typeface="Gautami"/>
+        <a:font script="Taml" typeface="Latha"/>
+        <a:font script="Syrc" typeface="Estrangelo Edessa"/>
+        <a:font script="Orya" typeface="Kalinga"/>
+        <a:font script="Mlym" typeface="Kartika"/>
+        <a:font script="Laoo" typeface="DokChampa"/>
+        <a:font script="Sinh" typeface="Iskoola Pota"/>
+        <a:font script="Mong" typeface="Mongolian Baiti"/>
+        <a:font script="Viet" typeface="Arial"/>
+        <a:font script="Uigh" typeface="Microsoft Uighur"/>
+        <a:font script="Geor" typeface="Sylfaen"/>
+        <a:font script="Armn" typeface="Arial"/>
+        <a:font script="Bugi" typeface="Leelawadee UI"/>
+        <a:font script="Bopo" typeface="Microsoft JhengHei"/>
+        <a:font script="Java" typeface="Javanese Text"/>
+        <a:font script="Lisu" typeface="Segoe UI"/>
+        <a:font script="Mymr" typeface="Myanmar Text"/>
+        <a:font script="Nkoo" typeface="Ebrima"/>
+        <a:font script="Olck" typeface="Nirmala UI"/>
+        <a:font script="Osma" typeface="Ebrima"/>
+        <a:font script="Phag" typeface="Phagspa"/>
+        <a:font script="Syrn" typeface="Estrangelo Edessa"/>
+        <a:font script="Syrj" typeface="Estrangelo Edessa"/>
+        <a:font script="Syre" typeface="Estrangelo Edessa"/>
+        <a:font script="Sora" typeface="Nirmala UI"/>
+        <a:font script="Tale" typeface="Microsoft Tai Le"/>
+        <a:font script="Talu" typeface="Microsoft New Tai Lue"/>
+        <a:font script="Tfng" typeface="Ebrima"/>
+      </a:minorFont>
+    </a:fontScheme>
+    <a:fmtScheme name="Office">
+      <a:fillStyleLst>
+        <a:solidFill>
+          <a:schemeClr val="phClr"/>
+        </a:solidFill>
+        <a:gradFill rotWithShape="1">
+          <a:gsLst>
+            <a:gs pos="0">
+              <a:schemeClr val="phClr">
+                <a:lumMod val="110000"/>
+                <a:satMod val="105000"/>
+                <a:tint val="67000"/>
+              </a:schemeClr>
+            </a:gs>
+            <a:gs pos="50000">
+              <a:schemeClr val="phClr">
+                <a:lumMod val="105000"/>
+                <a:satMod val="103000"/>
+                <a:tint val="73000"/>
+              </a:schemeClr>
+            </a:gs>
+            <a:gs pos="100000">
+              <a:schemeClr val="phClr">
+                <a:lumMod val="105000"/>
+                <a:satMod val="109000"/>
+                <a:tint val="81000"/>
+              </a:schemeClr>
+            </a:gs>
+          </a:gsLst>
+          <a:lin ang="5400000" scaled="0"/>
+        </a:gradFill>
+        <a:gradFill rotWithShape="1">
+          <a:gsLst>
+            <a:gs pos="0">
+              <a:schemeClr val="phClr">
+                <a:satMod val="103000"/>
+                <a:lumMod val="102000"/>
+                <a:tint val="94000"/>
+              </a:schemeClr>
+            </a:gs>
+            <a:gs pos="50000">
+              <a:schemeClr val="phClr">
+                <a:satMod val="110000"/>
+                <a:lumMod val="100000"/>
+                <a:shade val="100000"/>
+              </a:schemeClr>
+            </a:gs>
+            <a:gs pos="100000">
+              <a:schemeClr val="phClr">
+                <a:lumMod val="99000"/>
+                <a:satMod val="120000"/>
+                <a:shade val="78000"/>
+              </a:schemeClr>
+            </a:gs>
+          </a:gsLst>
+          <a:lin ang="5400000" scaled="0"/>
+        </a:gradFill>
+      </a:fillStyleLst>
+      <a:lnStyleLst>
+        <a:ln w="12700" cap="flat" cmpd="sng" algn="ctr">
+          <a:solidFill>
+            <a:schemeClr val="phClr"/>
+          </a:solidFill>
+          <a:prstDash val="solid"/>
+          <a:miter lim="800000"/>
+        </a:ln>
+        <a:ln w="19050" cap="flat" cmpd="sng" algn="ctr">
+          <a:solidFill>
+            <a:schemeClr val="phClr"/>
+          </a:solidFill>
+          <a:prstDash val="solid"/>
+          <a:miter lim="800000"/>
+        </a:ln>
+        <a:ln w="25400" cap="flat" cmpd="sng" algn="ctr">
+          <a:solidFill>
+            <a:schemeClr val="phClr"/>
+          </a:solidFill>
+          <a:prstDash val="solid"/>
+          <a:miter lim="800000"/>
+        </a:ln>
+      </a:lnStyleLst>
+      <a:effectStyleLst>
+        <a:effectStyle>
+          <a:effectLst/>
+        </a:effectStyle>
+        <a:effectStyle>
+          <a:effectLst/>
+        </a:effectStyle>
+        <a:effectStyle>
+          <a:effectLst>
+            <a:outerShdw blurRad="57150" dist="19050" dir="5400000" algn="ctr" rotWithShape="0">
+              <a:srgbClr val="000000">
+                <a:alpha val="63000"/>
+              </a:srgbClr>
+            </a:outerShdw>
+          </a:effectLst>
+        </a:effectStyle>
+      </a:effectStyleLst>
+      <a:bgFillStyleLst>
+        <a:solidFill>
+          <a:schemeClr val="phClr"/>
+        </a:solidFill>
+        <a:solidFill>
+          <a:schemeClr val="phClr">
+            <a:tint val="95000"/>
+            <a:satMod val="170000"/>
+          </a:schemeClr>
+        </a:solidFill>
+        <a:gradFill rotWithShape="1">
+          <a:gsLst>
+            <a:gs pos="0">
+              <a:schemeClr val="phClr">
+                <a:tint val="93000"/>
+                <a:satMod val="150000"/>
+                <a:shade val="98000"/>
+                <a:lumMod val="102000"/>
+              </a:schemeClr>
+            </a:gs>
+            <a:gs pos="50000">
+              <a:schemeClr val="phClr">
+                <a:tint val="98000"/>
+                <a:satMod val="130000"/>
+                <a:shade val="90000"/>
+                <a:lumMod val="103000"/>
+              </a:schemeClr>
+            </a:gs>
+            <a:gs pos="100000">
+              <a:schemeClr val="phClr">
+                <a:shade val="63000"/>
+                <a:satMod val="120000"/>
+              </a:schemeClr>
+            </a:gs>
+          </a:gsLst>
+          <a:lin ang="5400000" scaled="0"/>
+        </a:gradFill>
+      </a:bgFillStyleLst>
+    </a:fmtScheme>
+  </a:themeElements>
+  <a:objectDefaults>
+    <a:lnDef>
+      <a:spPr/>
+      <a:bodyPr/>
+      <a:lstStyle/>
+      <a:style>
+        <a:lnRef idx="2">
+          <a:schemeClr val="accent1"/>
+        </a:lnRef>
+        <a:fillRef idx="0">
+          <a:schemeClr val="accent1"/>
+        </a:fillRef>
+        <a:effectRef idx="1">
+          <a:schemeClr val="accent1"/>
+        </a:effectRef>
+        <a:fontRef idx="minor">
+          <a:schemeClr val="tx1"/>
+        </a:fontRef>
+      </a:style>
+    </a:lnDef>
+  </a:objectDefaults>
+  <a:extraClrSchemeLst/>
+  <a:extLst>
+    <a:ext uri="{05A4C25C-085E-4340-85A3-A5531E510DB2}">
+      <thm15:themeFamily xmlns:thm15="http://schemas.microsoft.com/office/thememl/2012/main" name="Office Theme" id="{2E142A2C-CD16-42D6-873A-C26D2A0506FA}" vid="{1BDDFF52-6CD6-40A5-AB3C-68EB2F1E4D0A}"/>
+    </a:ext>
+  </a:extLst>
+</a:theme>
 </file>
</xml_diff>